<commit_message>
Add notification hook and update settings, remove unused images
- Add notification.ps1 for Windows notifications
- Update Claude Code settings with notification hook
- Update Openloop_Cali.pptx presentation
- Add REPORT_FINAL.md (Openpilot report)
- Add REORGANIZE_PLAN.md (project reorganization plan)
- Remove p1_final.jpg and p5_final.jpg (unused matrix analysis images)

🤖 Generated with [Claude Code](https://claude.com/claude-code)

Co-Authored-By: Claude <noreply@anthropic.com>
</commit_message>
<xml_diff>
--- a/Openloop_Cali.pptx
+++ b/Openloop_Cali.pptx
@@ -12,11 +12,12 @@
     <p:sldId id="259" r:id="rId6"/>
     <p:sldId id="261" r:id="rId7"/>
     <p:sldId id="260" r:id="rId8"/>
-    <p:sldId id="263" r:id="rId9"/>
-    <p:sldId id="264" r:id="rId10"/>
-    <p:sldId id="265" r:id="rId11"/>
-    <p:sldId id="266" r:id="rId12"/>
-    <p:sldId id="267" r:id="rId13"/>
+    <p:sldId id="265" r:id="rId9"/>
+    <p:sldId id="266" r:id="rId10"/>
+    <p:sldId id="267" r:id="rId11"/>
+    <p:sldId id="269" r:id="rId12"/>
+    <p:sldId id="270" r:id="rId13"/>
+    <p:sldId id="271" r:id="rId14"/>
   </p:sldIdLst>
   <p:sldSz cx="12192000" cy="6858000"/>
   <p:notesSz cx="6858000" cy="9144000"/>
@@ -270,7 +271,7 @@
           <a:p>
             <a:fld id="{E64DDFCE-F530-4609-990F-8819CCA5CEDA}" type="datetimeFigureOut">
               <a:rPr lang="zh-TW" altLang="en-US" smtClean="0"/>
-              <a:t>2025/10/3</a:t>
+              <a:t>2025/10/8</a:t>
             </a:fld>
             <a:endParaRPr lang="zh-TW" altLang="en-US"/>
           </a:p>
@@ -468,7 +469,7 @@
           <a:p>
             <a:fld id="{E64DDFCE-F530-4609-990F-8819CCA5CEDA}" type="datetimeFigureOut">
               <a:rPr lang="zh-TW" altLang="en-US" smtClean="0"/>
-              <a:t>2025/10/3</a:t>
+              <a:t>2025/10/8</a:t>
             </a:fld>
             <a:endParaRPr lang="zh-TW" altLang="en-US"/>
           </a:p>
@@ -676,7 +677,7 @@
           <a:p>
             <a:fld id="{E64DDFCE-F530-4609-990F-8819CCA5CEDA}" type="datetimeFigureOut">
               <a:rPr lang="zh-TW" altLang="en-US" smtClean="0"/>
-              <a:t>2025/10/3</a:t>
+              <a:t>2025/10/8</a:t>
             </a:fld>
             <a:endParaRPr lang="zh-TW" altLang="en-US"/>
           </a:p>
@@ -874,7 +875,7 @@
           <a:p>
             <a:fld id="{E64DDFCE-F530-4609-990F-8819CCA5CEDA}" type="datetimeFigureOut">
               <a:rPr lang="zh-TW" altLang="en-US" smtClean="0"/>
-              <a:t>2025/10/3</a:t>
+              <a:t>2025/10/8</a:t>
             </a:fld>
             <a:endParaRPr lang="zh-TW" altLang="en-US"/>
           </a:p>
@@ -1149,7 +1150,7 @@
           <a:p>
             <a:fld id="{E64DDFCE-F530-4609-990F-8819CCA5CEDA}" type="datetimeFigureOut">
               <a:rPr lang="zh-TW" altLang="en-US" smtClean="0"/>
-              <a:t>2025/10/3</a:t>
+              <a:t>2025/10/8</a:t>
             </a:fld>
             <a:endParaRPr lang="zh-TW" altLang="en-US"/>
           </a:p>
@@ -1414,7 +1415,7 @@
           <a:p>
             <a:fld id="{E64DDFCE-F530-4609-990F-8819CCA5CEDA}" type="datetimeFigureOut">
               <a:rPr lang="zh-TW" altLang="en-US" smtClean="0"/>
-              <a:t>2025/10/3</a:t>
+              <a:t>2025/10/8</a:t>
             </a:fld>
             <a:endParaRPr lang="zh-TW" altLang="en-US"/>
           </a:p>
@@ -1826,7 +1827,7 @@
           <a:p>
             <a:fld id="{E64DDFCE-F530-4609-990F-8819CCA5CEDA}" type="datetimeFigureOut">
               <a:rPr lang="zh-TW" altLang="en-US" smtClean="0"/>
-              <a:t>2025/10/3</a:t>
+              <a:t>2025/10/8</a:t>
             </a:fld>
             <a:endParaRPr lang="zh-TW" altLang="en-US"/>
           </a:p>
@@ -1967,7 +1968,7 @@
           <a:p>
             <a:fld id="{E64DDFCE-F530-4609-990F-8819CCA5CEDA}" type="datetimeFigureOut">
               <a:rPr lang="zh-TW" altLang="en-US" smtClean="0"/>
-              <a:t>2025/10/3</a:t>
+              <a:t>2025/10/8</a:t>
             </a:fld>
             <a:endParaRPr lang="zh-TW" altLang="en-US"/>
           </a:p>
@@ -2080,7 +2081,7 @@
           <a:p>
             <a:fld id="{E64DDFCE-F530-4609-990F-8819CCA5CEDA}" type="datetimeFigureOut">
               <a:rPr lang="zh-TW" altLang="en-US" smtClean="0"/>
-              <a:t>2025/10/3</a:t>
+              <a:t>2025/10/8</a:t>
             </a:fld>
             <a:endParaRPr lang="zh-TW" altLang="en-US"/>
           </a:p>
@@ -2391,7 +2392,7 @@
           <a:p>
             <a:fld id="{E64DDFCE-F530-4609-990F-8819CCA5CEDA}" type="datetimeFigureOut">
               <a:rPr lang="zh-TW" altLang="en-US" smtClean="0"/>
-              <a:t>2025/10/3</a:t>
+              <a:t>2025/10/8</a:t>
             </a:fld>
             <a:endParaRPr lang="zh-TW" altLang="en-US"/>
           </a:p>
@@ -2679,7 +2680,7 @@
           <a:p>
             <a:fld id="{E64DDFCE-F530-4609-990F-8819CCA5CEDA}" type="datetimeFigureOut">
               <a:rPr lang="zh-TW" altLang="en-US" smtClean="0"/>
-              <a:t>2025/10/3</a:t>
+              <a:t>2025/10/8</a:t>
             </a:fld>
             <a:endParaRPr lang="zh-TW" altLang="en-US"/>
           </a:p>
@@ -2920,7 +2921,7 @@
           <a:p>
             <a:fld id="{E64DDFCE-F530-4609-990F-8819CCA5CEDA}" type="datetimeFigureOut">
               <a:rPr lang="zh-TW" altLang="en-US" smtClean="0"/>
-              <a:t>2025/10/3</a:t>
+              <a:t>2025/10/8</a:t>
             </a:fld>
             <a:endParaRPr lang="zh-TW" altLang="en-US"/>
           </a:p>
@@ -3531,6 +3532,48 @@
           </a:p>
         </p:txBody>
       </p:sp>
+      <p:sp>
+        <p:nvSpPr>
+          <p:cNvPr id="2" name="標題 1">
+            <a:extLst>
+              <a:ext uri="{FF2B5EF4-FFF2-40B4-BE49-F238E27FC236}">
+                <a16:creationId xmlns:a16="http://schemas.microsoft.com/office/drawing/2014/main" id="{599F252E-C55C-59F6-F069-5E85F602A251}"/>
+              </a:ext>
+            </a:extLst>
+          </p:cNvPr>
+          <p:cNvSpPr>
+            <a:spLocks noGrp="1"/>
+          </p:cNvSpPr>
+          <p:nvPr>
+            <p:ph type="title"/>
+          </p:nvPr>
+        </p:nvSpPr>
+        <p:spPr>
+          <a:xfrm>
+            <a:off x="11096897" y="0"/>
+            <a:ext cx="1095103" cy="662486"/>
+          </a:xfrm>
+        </p:spPr>
+        <p:txBody>
+          <a:bodyPr>
+            <a:normAutofit fontScale="90000"/>
+          </a:bodyPr>
+          <a:lstStyle/>
+          <a:p>
+            <a:r>
+              <a:rPr lang="en-US" altLang="zh-TW" dirty="0">
+                <a:latin typeface="Times New Roman" panose="02020603050405020304" pitchFamily="18" charset="0"/>
+                <a:cs typeface="Times New Roman" panose="02020603050405020304" pitchFamily="18" charset="0"/>
+              </a:rPr>
+              <a:t>9/30</a:t>
+            </a:r>
+            <a:endParaRPr lang="zh-TW" altLang="en-US" dirty="0">
+              <a:latin typeface="Times New Roman" panose="02020603050405020304" pitchFamily="18" charset="0"/>
+              <a:cs typeface="Times New Roman" panose="02020603050405020304" pitchFamily="18" charset="0"/>
+            </a:endParaRPr>
+          </a:p>
+        </p:txBody>
+      </p:sp>
     </p:spTree>
     <p:extLst>
       <p:ext uri="{BB962C8B-B14F-4D97-AF65-F5344CB8AC3E}">
@@ -3545,6 +3588,1823 @@
 </file>
 
 <file path=ppt/slides/slide10.xml><?xml version="1.0" encoding="utf-8"?>
+<p:sld xmlns:a="http://schemas.openxmlformats.org/drawingml/2006/main" xmlns:r="http://schemas.openxmlformats.org/officeDocument/2006/relationships" xmlns:p="http://schemas.openxmlformats.org/presentationml/2006/main">
+  <p:cSld>
+    <p:spTree>
+      <p:nvGrpSpPr>
+        <p:cNvPr id="1" name=""/>
+        <p:cNvGrpSpPr/>
+        <p:nvPr/>
+      </p:nvGrpSpPr>
+      <p:grpSpPr>
+        <a:xfrm>
+          <a:off x="0" y="0"/>
+          <a:ext cx="0" cy="0"/>
+          <a:chOff x="0" y="0"/>
+          <a:chExt cx="0" cy="0"/>
+        </a:xfrm>
+      </p:grpSpPr>
+      <p:pic>
+        <p:nvPicPr>
+          <p:cNvPr id="5" name="圖片 4" descr="一張含有 文字, 螢幕擷取畫面, 圖表, 行 的圖片&#10;&#10;AI 產生的內容可能不正確。">
+            <a:extLst>
+              <a:ext uri="{FF2B5EF4-FFF2-40B4-BE49-F238E27FC236}">
+                <a16:creationId xmlns:a16="http://schemas.microsoft.com/office/drawing/2014/main" id="{2E7A5474-1EE6-854C-FEF5-0A60015924BA}"/>
+              </a:ext>
+            </a:extLst>
+          </p:cNvPr>
+          <p:cNvPicPr>
+            <a:picLocks noChangeAspect="1"/>
+          </p:cNvPicPr>
+          <p:nvPr/>
+        </p:nvPicPr>
+        <p:blipFill>
+          <a:blip r:embed="rId2">
+            <a:extLst>
+              <a:ext uri="{28A0092B-C50C-407E-A947-70E740481C1C}">
+                <a14:useLocalDpi xmlns:a14="http://schemas.microsoft.com/office/drawing/2010/main" val="0"/>
+              </a:ext>
+            </a:extLst>
+          </a:blip>
+          <a:stretch>
+            <a:fillRect/>
+          </a:stretch>
+        </p:blipFill>
+        <p:spPr>
+          <a:xfrm>
+            <a:off x="0" y="1271603"/>
+            <a:ext cx="6096000" cy="5429504"/>
+          </a:xfrm>
+          <a:prstGeom prst="rect">
+            <a:avLst/>
+          </a:prstGeom>
+        </p:spPr>
+      </p:pic>
+      <p:pic>
+        <p:nvPicPr>
+          <p:cNvPr id="7" name="圖片 6" descr="一張含有 文字, 螢幕擷取畫面, 圖表, 行 的圖片&#10;&#10;AI 產生的內容可能不正確。">
+            <a:extLst>
+              <a:ext uri="{FF2B5EF4-FFF2-40B4-BE49-F238E27FC236}">
+                <a16:creationId xmlns:a16="http://schemas.microsoft.com/office/drawing/2014/main" id="{4DF2F87B-B605-34CF-9465-3BC543833D9B}"/>
+              </a:ext>
+            </a:extLst>
+          </p:cNvPr>
+          <p:cNvPicPr>
+            <a:picLocks noChangeAspect="1"/>
+          </p:cNvPicPr>
+          <p:nvPr/>
+        </p:nvPicPr>
+        <p:blipFill>
+          <a:blip r:embed="rId3">
+            <a:extLst>
+              <a:ext uri="{28A0092B-C50C-407E-A947-70E740481C1C}">
+                <a14:useLocalDpi xmlns:a14="http://schemas.microsoft.com/office/drawing/2010/main" val="0"/>
+              </a:ext>
+            </a:extLst>
+          </a:blip>
+          <a:stretch>
+            <a:fillRect/>
+          </a:stretch>
+        </p:blipFill>
+        <p:spPr>
+          <a:xfrm>
+            <a:off x="6096000" y="1271603"/>
+            <a:ext cx="6096000" cy="5429504"/>
+          </a:xfrm>
+          <a:prstGeom prst="rect">
+            <a:avLst/>
+          </a:prstGeom>
+        </p:spPr>
+      </p:pic>
+      <p:sp>
+        <p:nvSpPr>
+          <p:cNvPr id="2" name="標題 1">
+            <a:extLst>
+              <a:ext uri="{FF2B5EF4-FFF2-40B4-BE49-F238E27FC236}">
+                <a16:creationId xmlns:a16="http://schemas.microsoft.com/office/drawing/2014/main" id="{70EA8830-9EBB-3EC3-633D-7116F0887D45}"/>
+              </a:ext>
+            </a:extLst>
+          </p:cNvPr>
+          <p:cNvSpPr>
+            <a:spLocks noGrp="1"/>
+          </p:cNvSpPr>
+          <p:nvPr>
+            <p:ph type="title"/>
+          </p:nvPr>
+        </p:nvSpPr>
+        <p:spPr>
+          <a:xfrm>
+            <a:off x="11096897" y="0"/>
+            <a:ext cx="1095103" cy="662486"/>
+          </a:xfrm>
+        </p:spPr>
+        <p:txBody>
+          <a:bodyPr>
+            <a:normAutofit fontScale="90000"/>
+          </a:bodyPr>
+          <a:lstStyle/>
+          <a:p>
+            <a:r>
+              <a:rPr lang="en-US" altLang="zh-TW" dirty="0">
+                <a:latin typeface="Times New Roman" panose="02020603050405020304" pitchFamily="18" charset="0"/>
+                <a:cs typeface="Times New Roman" panose="02020603050405020304" pitchFamily="18" charset="0"/>
+              </a:rPr>
+              <a:t>10/2</a:t>
+            </a:r>
+            <a:endParaRPr lang="zh-TW" altLang="en-US" dirty="0">
+              <a:latin typeface="Times New Roman" panose="02020603050405020304" pitchFamily="18" charset="0"/>
+              <a:cs typeface="Times New Roman" panose="02020603050405020304" pitchFamily="18" charset="0"/>
+            </a:endParaRPr>
+          </a:p>
+        </p:txBody>
+      </p:sp>
+      <p:sp>
+        <p:nvSpPr>
+          <p:cNvPr id="3" name="文字方塊 2">
+            <a:extLst>
+              <a:ext uri="{FF2B5EF4-FFF2-40B4-BE49-F238E27FC236}">
+                <a16:creationId xmlns:a16="http://schemas.microsoft.com/office/drawing/2014/main" id="{10C8C060-EDFB-7790-2BC3-20DDF3F4714D}"/>
+              </a:ext>
+            </a:extLst>
+          </p:cNvPr>
+          <p:cNvSpPr txBox="1"/>
+          <p:nvPr/>
+        </p:nvSpPr>
+        <p:spPr>
+          <a:xfrm>
+            <a:off x="857251" y="343499"/>
+            <a:ext cx="9191624" cy="707886"/>
+          </a:xfrm>
+          <a:prstGeom prst="rect">
+            <a:avLst/>
+          </a:prstGeom>
+          <a:noFill/>
+        </p:spPr>
+        <p:txBody>
+          <a:bodyPr wrap="square" rtlCol="0">
+            <a:spAutoFit/>
+          </a:bodyPr>
+          <a:lstStyle/>
+          <a:p>
+            <a:r>
+              <a:rPr lang="en-US" altLang="zh-TW" sz="4000" dirty="0">
+                <a:latin typeface="Times New Roman" panose="02020603050405020304" pitchFamily="18" charset="0"/>
+                <a:cs typeface="Times New Roman" panose="02020603050405020304" pitchFamily="18" charset="0"/>
+              </a:rPr>
+              <a:t>Different </a:t>
+            </a:r>
+            <a:r>
+              <a:rPr lang="en-US" altLang="zh-TW" sz="4000" dirty="0" err="1">
+                <a:latin typeface="Times New Roman" panose="02020603050405020304" pitchFamily="18" charset="0"/>
+                <a:cs typeface="Times New Roman" panose="02020603050405020304" pitchFamily="18" charset="0"/>
+              </a:rPr>
+              <a:t>wc</a:t>
+            </a:r>
+            <a:r>
+              <a:rPr lang="en-US" altLang="zh-TW" sz="4000" dirty="0">
+                <a:latin typeface="Times New Roman" panose="02020603050405020304" pitchFamily="18" charset="0"/>
+                <a:cs typeface="Times New Roman" panose="02020603050405020304" pitchFamily="18" charset="0"/>
+              </a:rPr>
+              <a:t> comparison results</a:t>
+            </a:r>
+          </a:p>
+        </p:txBody>
+      </p:sp>
+    </p:spTree>
+    <p:extLst>
+      <p:ext uri="{BB962C8B-B14F-4D97-AF65-F5344CB8AC3E}">
+        <p14:creationId xmlns:p14="http://schemas.microsoft.com/office/powerpoint/2010/main" val="2088503058"/>
+      </p:ext>
+    </p:extLst>
+  </p:cSld>
+  <p:clrMapOvr>
+    <a:masterClrMapping/>
+  </p:clrMapOvr>
+</p:sld>
+</file>
+
+<file path=ppt/slides/slide11.xml><?xml version="1.0" encoding="utf-8"?>
+<p:sld xmlns:a="http://schemas.openxmlformats.org/drawingml/2006/main" xmlns:r="http://schemas.openxmlformats.org/officeDocument/2006/relationships" xmlns:p="http://schemas.openxmlformats.org/presentationml/2006/main">
+  <p:cSld>
+    <p:spTree>
+      <p:nvGrpSpPr>
+        <p:cNvPr id="1" name=""/>
+        <p:cNvGrpSpPr/>
+        <p:nvPr/>
+      </p:nvGrpSpPr>
+      <p:grpSpPr>
+        <a:xfrm>
+          <a:off x="0" y="0"/>
+          <a:ext cx="0" cy="0"/>
+          <a:chOff x="0" y="0"/>
+          <a:chExt cx="0" cy="0"/>
+        </a:xfrm>
+      </p:grpSpPr>
+      <p:sp>
+        <p:nvSpPr>
+          <p:cNvPr id="4" name="標題 1">
+            <a:extLst>
+              <a:ext uri="{FF2B5EF4-FFF2-40B4-BE49-F238E27FC236}">
+                <a16:creationId xmlns:a16="http://schemas.microsoft.com/office/drawing/2014/main" id="{2ABA570D-2711-2125-E15E-2503E9A7F835}"/>
+              </a:ext>
+            </a:extLst>
+          </p:cNvPr>
+          <p:cNvSpPr>
+            <a:spLocks noGrp="1"/>
+          </p:cNvSpPr>
+          <p:nvPr>
+            <p:ph type="title"/>
+          </p:nvPr>
+        </p:nvSpPr>
+        <p:spPr>
+          <a:xfrm>
+            <a:off x="11096897" y="0"/>
+            <a:ext cx="1095103" cy="662486"/>
+          </a:xfrm>
+        </p:spPr>
+        <p:txBody>
+          <a:bodyPr>
+            <a:normAutofit fontScale="90000"/>
+          </a:bodyPr>
+          <a:lstStyle/>
+          <a:p>
+            <a:r>
+              <a:rPr lang="en-US" altLang="zh-TW" dirty="0">
+                <a:latin typeface="Times New Roman" panose="02020603050405020304" pitchFamily="18" charset="0"/>
+                <a:cs typeface="Times New Roman" panose="02020603050405020304" pitchFamily="18" charset="0"/>
+              </a:rPr>
+              <a:t>10/8</a:t>
+            </a:r>
+            <a:endParaRPr lang="zh-TW" altLang="en-US" dirty="0">
+              <a:latin typeface="Times New Roman" panose="02020603050405020304" pitchFamily="18" charset="0"/>
+              <a:cs typeface="Times New Roman" panose="02020603050405020304" pitchFamily="18" charset="0"/>
+            </a:endParaRPr>
+          </a:p>
+        </p:txBody>
+      </p:sp>
+      <p:pic>
+        <p:nvPicPr>
+          <p:cNvPr id="9" name="圖片 8" descr="一張含有 文字, 螢幕擷取畫面, 字型, 數字 的圖片&#10;&#10;AI 產生的內容可能不正確。">
+            <a:extLst>
+              <a:ext uri="{FF2B5EF4-FFF2-40B4-BE49-F238E27FC236}">
+                <a16:creationId xmlns:a16="http://schemas.microsoft.com/office/drawing/2014/main" id="{54D898E0-2B15-3819-B022-73281E59F0D2}"/>
+              </a:ext>
+            </a:extLst>
+          </p:cNvPr>
+          <p:cNvPicPr>
+            <a:picLocks noChangeAspect="1"/>
+          </p:cNvPicPr>
+          <p:nvPr/>
+        </p:nvPicPr>
+        <p:blipFill>
+          <a:blip r:embed="rId2">
+            <a:extLst>
+              <a:ext uri="{28A0092B-C50C-407E-A947-70E740481C1C}">
+                <a14:useLocalDpi xmlns:a14="http://schemas.microsoft.com/office/drawing/2010/main" val="0"/>
+              </a:ext>
+            </a:extLst>
+          </a:blip>
+          <a:stretch>
+            <a:fillRect/>
+          </a:stretch>
+        </p:blipFill>
+        <p:spPr>
+          <a:xfrm>
+            <a:off x="381714" y="1048047"/>
+            <a:ext cx="11428571" cy="4761905"/>
+          </a:xfrm>
+          <a:prstGeom prst="rect">
+            <a:avLst/>
+          </a:prstGeom>
+        </p:spPr>
+      </p:pic>
+    </p:spTree>
+    <p:extLst>
+      <p:ext uri="{BB962C8B-B14F-4D97-AF65-F5344CB8AC3E}">
+        <p14:creationId xmlns:p14="http://schemas.microsoft.com/office/powerpoint/2010/main" val="1021454467"/>
+      </p:ext>
+    </p:extLst>
+  </p:cSld>
+  <p:clrMapOvr>
+    <a:masterClrMapping/>
+  </p:clrMapOvr>
+</p:sld>
+</file>
+
+<file path=ppt/slides/slide12.xml><?xml version="1.0" encoding="utf-8"?>
+<p:sld xmlns:a="http://schemas.openxmlformats.org/drawingml/2006/main" xmlns:r="http://schemas.openxmlformats.org/officeDocument/2006/relationships" xmlns:p="http://schemas.openxmlformats.org/presentationml/2006/main">
+  <p:cSld>
+    <p:spTree>
+      <p:nvGrpSpPr>
+        <p:cNvPr id="1" name="">
+          <a:extLst>
+            <a:ext uri="{FF2B5EF4-FFF2-40B4-BE49-F238E27FC236}">
+              <a16:creationId xmlns:a16="http://schemas.microsoft.com/office/drawing/2014/main" id="{FD1F4E16-DBB2-7AC4-F129-7DFFA879A184}"/>
+            </a:ext>
+          </a:extLst>
+        </p:cNvPr>
+        <p:cNvGrpSpPr/>
+        <p:nvPr/>
+      </p:nvGrpSpPr>
+      <p:grpSpPr>
+        <a:xfrm>
+          <a:off x="0" y="0"/>
+          <a:ext cx="0" cy="0"/>
+          <a:chOff x="0" y="0"/>
+          <a:chExt cx="0" cy="0"/>
+        </a:xfrm>
+      </p:grpSpPr>
+      <p:sp>
+        <p:nvSpPr>
+          <p:cNvPr id="4" name="標題 1">
+            <a:extLst>
+              <a:ext uri="{FF2B5EF4-FFF2-40B4-BE49-F238E27FC236}">
+                <a16:creationId xmlns:a16="http://schemas.microsoft.com/office/drawing/2014/main" id="{B39905A4-83DA-779A-DC73-EEAC91008CE0}"/>
+              </a:ext>
+            </a:extLst>
+          </p:cNvPr>
+          <p:cNvSpPr>
+            <a:spLocks noGrp="1"/>
+          </p:cNvSpPr>
+          <p:nvPr>
+            <p:ph type="title"/>
+          </p:nvPr>
+        </p:nvSpPr>
+        <p:spPr>
+          <a:xfrm>
+            <a:off x="11096897" y="0"/>
+            <a:ext cx="1095103" cy="662486"/>
+          </a:xfrm>
+        </p:spPr>
+        <p:txBody>
+          <a:bodyPr>
+            <a:normAutofit fontScale="90000"/>
+          </a:bodyPr>
+          <a:lstStyle/>
+          <a:p>
+            <a:r>
+              <a:rPr lang="en-US" altLang="zh-TW" dirty="0">
+                <a:latin typeface="Times New Roman" panose="02020603050405020304" pitchFamily="18" charset="0"/>
+                <a:cs typeface="Times New Roman" panose="02020603050405020304" pitchFamily="18" charset="0"/>
+              </a:rPr>
+              <a:t>10/8</a:t>
+            </a:r>
+            <a:endParaRPr lang="zh-TW" altLang="en-US" dirty="0">
+              <a:latin typeface="Times New Roman" panose="02020603050405020304" pitchFamily="18" charset="0"/>
+              <a:cs typeface="Times New Roman" panose="02020603050405020304" pitchFamily="18" charset="0"/>
+            </a:endParaRPr>
+          </a:p>
+        </p:txBody>
+      </p:sp>
+      <p:sp>
+        <p:nvSpPr>
+          <p:cNvPr id="2" name="文字方塊 1">
+            <a:extLst>
+              <a:ext uri="{FF2B5EF4-FFF2-40B4-BE49-F238E27FC236}">
+                <a16:creationId xmlns:a16="http://schemas.microsoft.com/office/drawing/2014/main" id="{10DCF78A-134D-26FA-5D04-99041926949E}"/>
+              </a:ext>
+            </a:extLst>
+          </p:cNvPr>
+          <p:cNvSpPr txBox="1"/>
+          <p:nvPr/>
+        </p:nvSpPr>
+        <p:spPr>
+          <a:xfrm>
+            <a:off x="857251" y="343499"/>
+            <a:ext cx="9191624" cy="707886"/>
+          </a:xfrm>
+          <a:prstGeom prst="rect">
+            <a:avLst/>
+          </a:prstGeom>
+          <a:noFill/>
+        </p:spPr>
+        <p:txBody>
+          <a:bodyPr wrap="square" rtlCol="0">
+            <a:spAutoFit/>
+          </a:bodyPr>
+          <a:lstStyle/>
+          <a:p>
+            <a:r>
+              <a:rPr lang="en-US" altLang="zh-TW" sz="4000" dirty="0">
+                <a:latin typeface="Times New Roman" panose="02020603050405020304" pitchFamily="18" charset="0"/>
+                <a:cs typeface="Times New Roman" panose="02020603050405020304" pitchFamily="18" charset="0"/>
+              </a:rPr>
+              <a:t>Dynamic Response Comparison</a:t>
+            </a:r>
+          </a:p>
+        </p:txBody>
+      </p:sp>
+      <p:pic>
+        <p:nvPicPr>
+          <p:cNvPr id="5" name="圖片 4" descr="一張含有 文字, 圖表, 行, 繪圖 的圖片&#10;&#10;AI 產生的內容可能不正確。">
+            <a:extLst>
+              <a:ext uri="{FF2B5EF4-FFF2-40B4-BE49-F238E27FC236}">
+                <a16:creationId xmlns:a16="http://schemas.microsoft.com/office/drawing/2014/main" id="{7C9FCE19-54EB-FA1B-9519-C1C300666766}"/>
+              </a:ext>
+            </a:extLst>
+          </p:cNvPr>
+          <p:cNvPicPr>
+            <a:picLocks noChangeAspect="1"/>
+          </p:cNvPicPr>
+          <p:nvPr/>
+        </p:nvPicPr>
+        <p:blipFill>
+          <a:blip r:embed="rId2">
+            <a:extLst>
+              <a:ext uri="{28A0092B-C50C-407E-A947-70E740481C1C}">
+                <a14:useLocalDpi xmlns:a14="http://schemas.microsoft.com/office/drawing/2010/main" val="0"/>
+              </a:ext>
+            </a:extLst>
+          </a:blip>
+          <a:stretch>
+            <a:fillRect/>
+          </a:stretch>
+        </p:blipFill>
+        <p:spPr>
+          <a:xfrm>
+            <a:off x="0" y="1909480"/>
+            <a:ext cx="6390171" cy="3334871"/>
+          </a:xfrm>
+          <a:prstGeom prst="rect">
+            <a:avLst/>
+          </a:prstGeom>
+        </p:spPr>
+      </p:pic>
+      <p:pic>
+        <p:nvPicPr>
+          <p:cNvPr id="7" name="圖片 6" descr="一張含有 文字, 圖表, 行, 繪圖 的圖片&#10;&#10;AI 產生的內容可能不正確。">
+            <a:extLst>
+              <a:ext uri="{FF2B5EF4-FFF2-40B4-BE49-F238E27FC236}">
+                <a16:creationId xmlns:a16="http://schemas.microsoft.com/office/drawing/2014/main" id="{338080CD-C856-85AF-B03E-D1A3602225C5}"/>
+              </a:ext>
+            </a:extLst>
+          </p:cNvPr>
+          <p:cNvPicPr>
+            <a:picLocks noChangeAspect="1"/>
+          </p:cNvPicPr>
+          <p:nvPr/>
+        </p:nvPicPr>
+        <p:blipFill>
+          <a:blip r:embed="rId3">
+            <a:extLst>
+              <a:ext uri="{28A0092B-C50C-407E-A947-70E740481C1C}">
+                <a14:useLocalDpi xmlns:a14="http://schemas.microsoft.com/office/drawing/2010/main" val="0"/>
+              </a:ext>
+            </a:extLst>
+          </a:blip>
+          <a:stretch>
+            <a:fillRect/>
+          </a:stretch>
+        </p:blipFill>
+        <p:spPr>
+          <a:xfrm>
+            <a:off x="5801829" y="1909481"/>
+            <a:ext cx="6390171" cy="3334871"/>
+          </a:xfrm>
+          <a:prstGeom prst="rect">
+            <a:avLst/>
+          </a:prstGeom>
+        </p:spPr>
+      </p:pic>
+    </p:spTree>
+    <p:extLst>
+      <p:ext uri="{BB962C8B-B14F-4D97-AF65-F5344CB8AC3E}">
+        <p14:creationId xmlns:p14="http://schemas.microsoft.com/office/powerpoint/2010/main" val="1804635208"/>
+      </p:ext>
+    </p:extLst>
+  </p:cSld>
+  <p:clrMapOvr>
+    <a:masterClrMapping/>
+  </p:clrMapOvr>
+</p:sld>
+</file>
+
+<file path=ppt/slides/slide13.xml><?xml version="1.0" encoding="utf-8"?>
+<p:sld xmlns:a="http://schemas.openxmlformats.org/drawingml/2006/main" xmlns:r="http://schemas.openxmlformats.org/officeDocument/2006/relationships" xmlns:p="http://schemas.openxmlformats.org/presentationml/2006/main">
+  <p:cSld>
+    <p:spTree>
+      <p:nvGrpSpPr>
+        <p:cNvPr id="1" name="">
+          <a:extLst>
+            <a:ext uri="{FF2B5EF4-FFF2-40B4-BE49-F238E27FC236}">
+              <a16:creationId xmlns:a16="http://schemas.microsoft.com/office/drawing/2014/main" id="{0E2510FF-9BB6-CA78-A0F0-072085D2C71C}"/>
+            </a:ext>
+          </a:extLst>
+        </p:cNvPr>
+        <p:cNvGrpSpPr/>
+        <p:nvPr/>
+      </p:nvGrpSpPr>
+      <p:grpSpPr>
+        <a:xfrm>
+          <a:off x="0" y="0"/>
+          <a:ext cx="0" cy="0"/>
+          <a:chOff x="0" y="0"/>
+          <a:chExt cx="0" cy="0"/>
+        </a:xfrm>
+      </p:grpSpPr>
+      <p:pic>
+        <p:nvPicPr>
+          <p:cNvPr id="3" name="圖片 2" descr="一張含有 文字, 圖表, 行, 繪圖 的圖片&#10;&#10;AI 產生的內容可能不正確。">
+            <a:extLst>
+              <a:ext uri="{FF2B5EF4-FFF2-40B4-BE49-F238E27FC236}">
+                <a16:creationId xmlns:a16="http://schemas.microsoft.com/office/drawing/2014/main" id="{3FF28765-79DF-7C08-6B7E-191A9C72B546}"/>
+              </a:ext>
+            </a:extLst>
+          </p:cNvPr>
+          <p:cNvPicPr>
+            <a:picLocks noChangeAspect="1"/>
+          </p:cNvPicPr>
+          <p:nvPr/>
+        </p:nvPicPr>
+        <p:blipFill>
+          <a:blip r:embed="rId2">
+            <a:extLst>
+              <a:ext uri="{28A0092B-C50C-407E-A947-70E740481C1C}">
+                <a14:useLocalDpi xmlns:a14="http://schemas.microsoft.com/office/drawing/2010/main" val="0"/>
+              </a:ext>
+            </a:extLst>
+          </a:blip>
+          <a:stretch>
+            <a:fillRect/>
+          </a:stretch>
+        </p:blipFill>
+        <p:spPr>
+          <a:xfrm>
+            <a:off x="0" y="300318"/>
+            <a:ext cx="5995080" cy="3128682"/>
+          </a:xfrm>
+          <a:prstGeom prst="rect">
+            <a:avLst/>
+          </a:prstGeom>
+        </p:spPr>
+      </p:pic>
+      <p:pic>
+        <p:nvPicPr>
+          <p:cNvPr id="6" name="圖片 5" descr="一張含有 文字, 圖表, 行, 繪圖 的圖片&#10;&#10;AI 產生的內容可能不正確。">
+            <a:extLst>
+              <a:ext uri="{FF2B5EF4-FFF2-40B4-BE49-F238E27FC236}">
+                <a16:creationId xmlns:a16="http://schemas.microsoft.com/office/drawing/2014/main" id="{EE00DE5C-2BD7-C2EA-7245-A64BBDE743F3}"/>
+              </a:ext>
+            </a:extLst>
+          </p:cNvPr>
+          <p:cNvPicPr>
+            <a:picLocks noChangeAspect="1"/>
+          </p:cNvPicPr>
+          <p:nvPr/>
+        </p:nvPicPr>
+        <p:blipFill>
+          <a:blip r:embed="rId3">
+            <a:extLst>
+              <a:ext uri="{28A0092B-C50C-407E-A947-70E740481C1C}">
+                <a14:useLocalDpi xmlns:a14="http://schemas.microsoft.com/office/drawing/2010/main" val="0"/>
+              </a:ext>
+            </a:extLst>
+          </a:blip>
+          <a:stretch>
+            <a:fillRect/>
+          </a:stretch>
+        </p:blipFill>
+        <p:spPr>
+          <a:xfrm>
+            <a:off x="6096000" y="300318"/>
+            <a:ext cx="5995080" cy="3128682"/>
+          </a:xfrm>
+          <a:prstGeom prst="rect">
+            <a:avLst/>
+          </a:prstGeom>
+        </p:spPr>
+      </p:pic>
+      <p:pic>
+        <p:nvPicPr>
+          <p:cNvPr id="8" name="圖片 7" descr="一張含有 文字, 圖表, 行, 繪圖 的圖片&#10;&#10;AI 產生的內容可能不正確。">
+            <a:extLst>
+              <a:ext uri="{FF2B5EF4-FFF2-40B4-BE49-F238E27FC236}">
+                <a16:creationId xmlns:a16="http://schemas.microsoft.com/office/drawing/2014/main" id="{E74B1B41-1B28-A0CE-2357-A1C02EFD3F01}"/>
+              </a:ext>
+            </a:extLst>
+          </p:cNvPr>
+          <p:cNvPicPr>
+            <a:picLocks noChangeAspect="1"/>
+          </p:cNvPicPr>
+          <p:nvPr/>
+        </p:nvPicPr>
+        <p:blipFill>
+          <a:blip r:embed="rId4">
+            <a:extLst>
+              <a:ext uri="{28A0092B-C50C-407E-A947-70E740481C1C}">
+                <a14:useLocalDpi xmlns:a14="http://schemas.microsoft.com/office/drawing/2010/main" val="0"/>
+              </a:ext>
+            </a:extLst>
+          </a:blip>
+          <a:stretch>
+            <a:fillRect/>
+          </a:stretch>
+        </p:blipFill>
+        <p:spPr>
+          <a:xfrm>
+            <a:off x="100920" y="3729318"/>
+            <a:ext cx="5995080" cy="3128682"/>
+          </a:xfrm>
+          <a:prstGeom prst="rect">
+            <a:avLst/>
+          </a:prstGeom>
+        </p:spPr>
+      </p:pic>
+      <p:pic>
+        <p:nvPicPr>
+          <p:cNvPr id="10" name="圖片 9" descr="一張含有 文字, 圖表, 行, 繪圖 的圖片&#10;&#10;AI 產生的內容可能不正確。">
+            <a:extLst>
+              <a:ext uri="{FF2B5EF4-FFF2-40B4-BE49-F238E27FC236}">
+                <a16:creationId xmlns:a16="http://schemas.microsoft.com/office/drawing/2014/main" id="{231B6379-33F4-9812-F7BA-C69B6B65D76E}"/>
+              </a:ext>
+            </a:extLst>
+          </p:cNvPr>
+          <p:cNvPicPr>
+            <a:picLocks noChangeAspect="1"/>
+          </p:cNvPicPr>
+          <p:nvPr/>
+        </p:nvPicPr>
+        <p:blipFill>
+          <a:blip r:embed="rId5">
+            <a:extLst>
+              <a:ext uri="{28A0092B-C50C-407E-A947-70E740481C1C}">
+                <a14:useLocalDpi xmlns:a14="http://schemas.microsoft.com/office/drawing/2010/main" val="0"/>
+              </a:ext>
+            </a:extLst>
+          </a:blip>
+          <a:stretch>
+            <a:fillRect/>
+          </a:stretch>
+        </p:blipFill>
+        <p:spPr>
+          <a:xfrm>
+            <a:off x="6096000" y="3729318"/>
+            <a:ext cx="5995080" cy="3128682"/>
+          </a:xfrm>
+          <a:prstGeom prst="rect">
+            <a:avLst/>
+          </a:prstGeom>
+        </p:spPr>
+      </p:pic>
+    </p:spTree>
+    <p:extLst>
+      <p:ext uri="{BB962C8B-B14F-4D97-AF65-F5344CB8AC3E}">
+        <p14:creationId xmlns:p14="http://schemas.microsoft.com/office/powerpoint/2010/main" val="539650019"/>
+      </p:ext>
+    </p:extLst>
+  </p:cSld>
+  <p:clrMapOvr>
+    <a:masterClrMapping/>
+  </p:clrMapOvr>
+</p:sld>
+</file>
+
+<file path=ppt/slides/slide2.xml><?xml version="1.0" encoding="utf-8"?>
+<p:sld xmlns:a="http://schemas.openxmlformats.org/drawingml/2006/main" xmlns:r="http://schemas.openxmlformats.org/officeDocument/2006/relationships" xmlns:p="http://schemas.openxmlformats.org/presentationml/2006/main">
+  <p:cSld>
+    <p:spTree>
+      <p:nvGrpSpPr>
+        <p:cNvPr id="1" name=""/>
+        <p:cNvGrpSpPr/>
+        <p:nvPr/>
+      </p:nvGrpSpPr>
+      <p:grpSpPr>
+        <a:xfrm>
+          <a:off x="0" y="0"/>
+          <a:ext cx="0" cy="0"/>
+          <a:chOff x="0" y="0"/>
+          <a:chExt cx="0" cy="0"/>
+        </a:xfrm>
+      </p:grpSpPr>
+      <p:pic>
+        <p:nvPicPr>
+          <p:cNvPr id="5" name="圖片 4">
+            <a:extLst>
+              <a:ext uri="{FF2B5EF4-FFF2-40B4-BE49-F238E27FC236}">
+                <a16:creationId xmlns:a16="http://schemas.microsoft.com/office/drawing/2014/main" id="{87927162-16B5-D086-B58F-9379DA7CE8AD}"/>
+              </a:ext>
+            </a:extLst>
+          </p:cNvPr>
+          <p:cNvPicPr>
+            <a:picLocks noChangeAspect="1"/>
+          </p:cNvPicPr>
+          <p:nvPr/>
+        </p:nvPicPr>
+        <p:blipFill>
+          <a:blip r:embed="rId2"/>
+          <a:stretch>
+            <a:fillRect/>
+          </a:stretch>
+        </p:blipFill>
+        <p:spPr>
+          <a:xfrm>
+            <a:off x="2064295" y="1680886"/>
+            <a:ext cx="8063409" cy="4479672"/>
+          </a:xfrm>
+          <a:prstGeom prst="rect">
+            <a:avLst/>
+          </a:prstGeom>
+        </p:spPr>
+      </p:pic>
+      <p:sp>
+        <p:nvSpPr>
+          <p:cNvPr id="6" name="文字方塊 5">
+            <a:extLst>
+              <a:ext uri="{FF2B5EF4-FFF2-40B4-BE49-F238E27FC236}">
+                <a16:creationId xmlns:a16="http://schemas.microsoft.com/office/drawing/2014/main" id="{2743031D-214E-AC92-DDC6-69FB539A6DD4}"/>
+              </a:ext>
+            </a:extLst>
+          </p:cNvPr>
+          <p:cNvSpPr txBox="1"/>
+          <p:nvPr/>
+        </p:nvSpPr>
+        <p:spPr>
+          <a:xfrm>
+            <a:off x="857251" y="343499"/>
+            <a:ext cx="7458074" cy="707886"/>
+          </a:xfrm>
+          <a:prstGeom prst="rect">
+            <a:avLst/>
+          </a:prstGeom>
+          <a:noFill/>
+        </p:spPr>
+        <p:txBody>
+          <a:bodyPr wrap="square" rtlCol="0">
+            <a:spAutoFit/>
+          </a:bodyPr>
+          <a:lstStyle/>
+          <a:p>
+            <a:r>
+              <a:rPr lang="en-US" altLang="zh-TW" sz="4000" dirty="0">
+                <a:latin typeface="Times New Roman" panose="02020603050405020304" pitchFamily="18" charset="0"/>
+                <a:cs typeface="Times New Roman" panose="02020603050405020304" pitchFamily="18" charset="0"/>
+              </a:rPr>
+              <a:t>Fitting with Original Phase Data</a:t>
+            </a:r>
+          </a:p>
+        </p:txBody>
+      </p:sp>
+      <p:sp>
+        <p:nvSpPr>
+          <p:cNvPr id="2" name="標題 1">
+            <a:extLst>
+              <a:ext uri="{FF2B5EF4-FFF2-40B4-BE49-F238E27FC236}">
+                <a16:creationId xmlns:a16="http://schemas.microsoft.com/office/drawing/2014/main" id="{2E81A2BD-9BB8-77EB-6326-EC6C97055A98}"/>
+              </a:ext>
+            </a:extLst>
+          </p:cNvPr>
+          <p:cNvSpPr txBox="1">
+            <a:spLocks/>
+          </p:cNvSpPr>
+          <p:nvPr/>
+        </p:nvSpPr>
+        <p:spPr>
+          <a:xfrm>
+            <a:off x="11096897" y="0"/>
+            <a:ext cx="1095103" cy="662486"/>
+          </a:xfrm>
+          <a:prstGeom prst="rect">
+            <a:avLst/>
+          </a:prstGeom>
+        </p:spPr>
+        <p:txBody>
+          <a:bodyPr vert="horz" lIns="91440" tIns="45720" rIns="91440" bIns="45720" rtlCol="0" anchor="b">
+            <a:normAutofit fontScale="60000" lnSpcReduction="20000"/>
+          </a:bodyPr>
+          <a:lstStyle>
+            <a:lvl1pPr algn="ctr" defTabSz="914400" rtl="0" eaLnBrk="1" latinLnBrk="0" hangingPunct="1">
+              <a:lnSpc>
+                <a:spcPct val="90000"/>
+              </a:lnSpc>
+              <a:spcBef>
+                <a:spcPct val="0"/>
+              </a:spcBef>
+              <a:buNone/>
+              <a:defRPr sz="6000" kern="1200">
+                <a:solidFill>
+                  <a:schemeClr val="tx1"/>
+                </a:solidFill>
+                <a:latin typeface="+mj-lt"/>
+                <a:ea typeface="+mj-ea"/>
+                <a:cs typeface="+mj-cs"/>
+              </a:defRPr>
+            </a:lvl1pPr>
+          </a:lstStyle>
+          <a:p>
+            <a:r>
+              <a:rPr lang="en-US" altLang="zh-TW">
+                <a:latin typeface="Times New Roman" panose="02020603050405020304" pitchFamily="18" charset="0"/>
+                <a:cs typeface="Times New Roman" panose="02020603050405020304" pitchFamily="18" charset="0"/>
+              </a:rPr>
+              <a:t>9/30</a:t>
+            </a:r>
+            <a:endParaRPr lang="zh-TW" altLang="en-US" dirty="0">
+              <a:latin typeface="Times New Roman" panose="02020603050405020304" pitchFamily="18" charset="0"/>
+              <a:cs typeface="Times New Roman" panose="02020603050405020304" pitchFamily="18" charset="0"/>
+            </a:endParaRPr>
+          </a:p>
+        </p:txBody>
+      </p:sp>
+    </p:spTree>
+    <p:extLst>
+      <p:ext uri="{BB962C8B-B14F-4D97-AF65-F5344CB8AC3E}">
+        <p14:creationId xmlns:p14="http://schemas.microsoft.com/office/powerpoint/2010/main" val="1387276854"/>
+      </p:ext>
+    </p:extLst>
+  </p:cSld>
+  <p:clrMapOvr>
+    <a:masterClrMapping/>
+  </p:clrMapOvr>
+</p:sld>
+</file>
+
+<file path=ppt/slides/slide3.xml><?xml version="1.0" encoding="utf-8"?>
+<p:sld xmlns:a="http://schemas.openxmlformats.org/drawingml/2006/main" xmlns:r="http://schemas.openxmlformats.org/officeDocument/2006/relationships" xmlns:p="http://schemas.openxmlformats.org/presentationml/2006/main">
+  <p:cSld>
+    <p:spTree>
+      <p:nvGrpSpPr>
+        <p:cNvPr id="1" name=""/>
+        <p:cNvGrpSpPr/>
+        <p:nvPr/>
+      </p:nvGrpSpPr>
+      <p:grpSpPr>
+        <a:xfrm>
+          <a:off x="0" y="0"/>
+          <a:ext cx="0" cy="0"/>
+          <a:chOff x="0" y="0"/>
+          <a:chExt cx="0" cy="0"/>
+        </a:xfrm>
+      </p:grpSpPr>
+      <p:pic>
+        <p:nvPicPr>
+          <p:cNvPr id="5" name="圖片 4" descr="一張含有 文字, 圖表, 螢幕擷取畫面, 行 的圖片&#10;&#10;AI 產生的內容可能不正確。">
+            <a:extLst>
+              <a:ext uri="{FF2B5EF4-FFF2-40B4-BE49-F238E27FC236}">
+                <a16:creationId xmlns:a16="http://schemas.microsoft.com/office/drawing/2014/main" id="{76B56E03-2F13-0787-7FA0-CD08ABFE67F5}"/>
+              </a:ext>
+            </a:extLst>
+          </p:cNvPr>
+          <p:cNvPicPr>
+            <a:picLocks noChangeAspect="1"/>
+          </p:cNvPicPr>
+          <p:nvPr/>
+        </p:nvPicPr>
+        <p:blipFill>
+          <a:blip r:embed="rId2">
+            <a:extLst>
+              <a:ext uri="{28A0092B-C50C-407E-A947-70E740481C1C}">
+                <a14:useLocalDpi xmlns:a14="http://schemas.microsoft.com/office/drawing/2010/main" val="0"/>
+              </a:ext>
+            </a:extLst>
+          </a:blip>
+          <a:stretch>
+            <a:fillRect/>
+          </a:stretch>
+        </p:blipFill>
+        <p:spPr>
+          <a:xfrm>
+            <a:off x="276226" y="2123816"/>
+            <a:ext cx="6029324" cy="3146554"/>
+          </a:xfrm>
+          <a:prstGeom prst="rect">
+            <a:avLst/>
+          </a:prstGeom>
+        </p:spPr>
+      </p:pic>
+      <p:pic>
+        <p:nvPicPr>
+          <p:cNvPr id="7" name="圖片 6" descr="一張含有 文字, 圖表, 螢幕擷取畫面, 行 的圖片&#10;&#10;AI 產生的內容可能不正確。">
+            <a:extLst>
+              <a:ext uri="{FF2B5EF4-FFF2-40B4-BE49-F238E27FC236}">
+                <a16:creationId xmlns:a16="http://schemas.microsoft.com/office/drawing/2014/main" id="{0FC02AC8-796F-A093-9852-61F082A17D09}"/>
+              </a:ext>
+            </a:extLst>
+          </p:cNvPr>
+          <p:cNvPicPr>
+            <a:picLocks noChangeAspect="1"/>
+          </p:cNvPicPr>
+          <p:nvPr/>
+        </p:nvPicPr>
+        <p:blipFill>
+          <a:blip r:embed="rId3">
+            <a:extLst>
+              <a:ext uri="{28A0092B-C50C-407E-A947-70E740481C1C}">
+                <a14:useLocalDpi xmlns:a14="http://schemas.microsoft.com/office/drawing/2010/main" val="0"/>
+              </a:ext>
+            </a:extLst>
+          </a:blip>
+          <a:stretch>
+            <a:fillRect/>
+          </a:stretch>
+        </p:blipFill>
+        <p:spPr>
+          <a:xfrm>
+            <a:off x="6162676" y="2123816"/>
+            <a:ext cx="6029324" cy="3146554"/>
+          </a:xfrm>
+          <a:prstGeom prst="rect">
+            <a:avLst/>
+          </a:prstGeom>
+        </p:spPr>
+      </p:pic>
+      <p:sp>
+        <p:nvSpPr>
+          <p:cNvPr id="11" name="文字方塊 10">
+            <a:extLst>
+              <a:ext uri="{FF2B5EF4-FFF2-40B4-BE49-F238E27FC236}">
+                <a16:creationId xmlns:a16="http://schemas.microsoft.com/office/drawing/2014/main" id="{530EB3E9-62D0-DC8E-0EA6-B3F37FE245E3}"/>
+              </a:ext>
+            </a:extLst>
+          </p:cNvPr>
+          <p:cNvSpPr txBox="1"/>
+          <p:nvPr/>
+        </p:nvSpPr>
+        <p:spPr>
+          <a:xfrm>
+            <a:off x="857251" y="343499"/>
+            <a:ext cx="7458074" cy="707886"/>
+          </a:xfrm>
+          <a:prstGeom prst="rect">
+            <a:avLst/>
+          </a:prstGeom>
+          <a:noFill/>
+        </p:spPr>
+        <p:txBody>
+          <a:bodyPr wrap="square" rtlCol="0">
+            <a:spAutoFit/>
+          </a:bodyPr>
+          <a:lstStyle/>
+          <a:p>
+            <a:r>
+              <a:rPr lang="en-US" altLang="zh-TW" sz="4000" dirty="0">
+                <a:latin typeface="Times New Roman" panose="02020603050405020304" pitchFamily="18" charset="0"/>
+                <a:cs typeface="Times New Roman" panose="02020603050405020304" pitchFamily="18" charset="0"/>
+              </a:rPr>
+              <a:t>Fitting with Original Phase Data</a:t>
+            </a:r>
+          </a:p>
+        </p:txBody>
+      </p:sp>
+      <p:sp>
+        <p:nvSpPr>
+          <p:cNvPr id="2" name="標題 1">
+            <a:extLst>
+              <a:ext uri="{FF2B5EF4-FFF2-40B4-BE49-F238E27FC236}">
+                <a16:creationId xmlns:a16="http://schemas.microsoft.com/office/drawing/2014/main" id="{E2C5838F-8AA7-02B9-41C2-D4532E075F80}"/>
+              </a:ext>
+            </a:extLst>
+          </p:cNvPr>
+          <p:cNvSpPr>
+            <a:spLocks noGrp="1"/>
+          </p:cNvSpPr>
+          <p:nvPr>
+            <p:ph type="title"/>
+          </p:nvPr>
+        </p:nvSpPr>
+        <p:spPr>
+          <a:xfrm>
+            <a:off x="11096897" y="0"/>
+            <a:ext cx="1095103" cy="662486"/>
+          </a:xfrm>
+        </p:spPr>
+        <p:txBody>
+          <a:bodyPr>
+            <a:normAutofit fontScale="90000"/>
+          </a:bodyPr>
+          <a:lstStyle/>
+          <a:p>
+            <a:r>
+              <a:rPr lang="en-US" altLang="zh-TW" dirty="0">
+                <a:latin typeface="Times New Roman" panose="02020603050405020304" pitchFamily="18" charset="0"/>
+                <a:cs typeface="Times New Roman" panose="02020603050405020304" pitchFamily="18" charset="0"/>
+              </a:rPr>
+              <a:t>9/30</a:t>
+            </a:r>
+            <a:endParaRPr lang="zh-TW" altLang="en-US" dirty="0">
+              <a:latin typeface="Times New Roman" panose="02020603050405020304" pitchFamily="18" charset="0"/>
+              <a:cs typeface="Times New Roman" panose="02020603050405020304" pitchFamily="18" charset="0"/>
+            </a:endParaRPr>
+          </a:p>
+        </p:txBody>
+      </p:sp>
+    </p:spTree>
+    <p:extLst>
+      <p:ext uri="{BB962C8B-B14F-4D97-AF65-F5344CB8AC3E}">
+        <p14:creationId xmlns:p14="http://schemas.microsoft.com/office/powerpoint/2010/main" val="3566969151"/>
+      </p:ext>
+    </p:extLst>
+  </p:cSld>
+  <p:clrMapOvr>
+    <a:masterClrMapping/>
+  </p:clrMapOvr>
+</p:sld>
+</file>
+
+<file path=ppt/slides/slide4.xml><?xml version="1.0" encoding="utf-8"?>
+<p:sld xmlns:a="http://schemas.openxmlformats.org/drawingml/2006/main" xmlns:r="http://schemas.openxmlformats.org/officeDocument/2006/relationships" xmlns:p="http://schemas.openxmlformats.org/presentationml/2006/main">
+  <p:cSld>
+    <p:spTree>
+      <p:nvGrpSpPr>
+        <p:cNvPr id="1" name=""/>
+        <p:cNvGrpSpPr/>
+        <p:nvPr/>
+      </p:nvGrpSpPr>
+      <p:grpSpPr>
+        <a:xfrm>
+          <a:off x="0" y="0"/>
+          <a:ext cx="0" cy="0"/>
+          <a:chOff x="0" y="0"/>
+          <a:chExt cx="0" cy="0"/>
+        </a:xfrm>
+      </p:grpSpPr>
+      <p:pic>
+        <p:nvPicPr>
+          <p:cNvPr id="9" name="圖片 8" descr="一張含有 文字, 螢幕擷取畫面, 行, 圖表 的圖片&#10;&#10;AI 產生的內容可能不正確。">
+            <a:extLst>
+              <a:ext uri="{FF2B5EF4-FFF2-40B4-BE49-F238E27FC236}">
+                <a16:creationId xmlns:a16="http://schemas.microsoft.com/office/drawing/2014/main" id="{CC9F8A7C-C7EB-13AD-14C4-45486C82BCF3}"/>
+              </a:ext>
+            </a:extLst>
+          </p:cNvPr>
+          <p:cNvPicPr>
+            <a:picLocks noChangeAspect="1"/>
+          </p:cNvPicPr>
+          <p:nvPr/>
+        </p:nvPicPr>
+        <p:blipFill>
+          <a:blip r:embed="rId2">
+            <a:extLst>
+              <a:ext uri="{28A0092B-C50C-407E-A947-70E740481C1C}">
+                <a14:useLocalDpi xmlns:a14="http://schemas.microsoft.com/office/drawing/2010/main" val="0"/>
+              </a:ext>
+            </a:extLst>
+          </a:blip>
+          <a:stretch>
+            <a:fillRect/>
+          </a:stretch>
+        </p:blipFill>
+        <p:spPr>
+          <a:xfrm>
+            <a:off x="66676" y="282446"/>
+            <a:ext cx="6029324" cy="3146554"/>
+          </a:xfrm>
+          <a:prstGeom prst="rect">
+            <a:avLst/>
+          </a:prstGeom>
+        </p:spPr>
+      </p:pic>
+      <p:pic>
+        <p:nvPicPr>
+          <p:cNvPr id="11" name="圖片 10" descr="一張含有 文字, 螢幕擷取畫面, 圖表, 行 的圖片&#10;&#10;AI 產生的內容可能不正確。">
+            <a:extLst>
+              <a:ext uri="{FF2B5EF4-FFF2-40B4-BE49-F238E27FC236}">
+                <a16:creationId xmlns:a16="http://schemas.microsoft.com/office/drawing/2014/main" id="{9705C1BC-2F92-921F-714D-577BBB25F487}"/>
+              </a:ext>
+            </a:extLst>
+          </p:cNvPr>
+          <p:cNvPicPr>
+            <a:picLocks noChangeAspect="1"/>
+          </p:cNvPicPr>
+          <p:nvPr/>
+        </p:nvPicPr>
+        <p:blipFill>
+          <a:blip r:embed="rId3">
+            <a:extLst>
+              <a:ext uri="{28A0092B-C50C-407E-A947-70E740481C1C}">
+                <a14:useLocalDpi xmlns:a14="http://schemas.microsoft.com/office/drawing/2010/main" val="0"/>
+              </a:ext>
+            </a:extLst>
+          </a:blip>
+          <a:stretch>
+            <a:fillRect/>
+          </a:stretch>
+        </p:blipFill>
+        <p:spPr>
+          <a:xfrm>
+            <a:off x="6096000" y="282446"/>
+            <a:ext cx="6029324" cy="3146554"/>
+          </a:xfrm>
+          <a:prstGeom prst="rect">
+            <a:avLst/>
+          </a:prstGeom>
+        </p:spPr>
+      </p:pic>
+      <p:pic>
+        <p:nvPicPr>
+          <p:cNvPr id="13" name="圖片 12" descr="一張含有 文字, 圖表, 螢幕擷取畫面, 行 的圖片&#10;&#10;AI 產生的內容可能不正確。">
+            <a:extLst>
+              <a:ext uri="{FF2B5EF4-FFF2-40B4-BE49-F238E27FC236}">
+                <a16:creationId xmlns:a16="http://schemas.microsoft.com/office/drawing/2014/main" id="{6212B6EC-44DF-DF8E-1309-106A0FBC20C7}"/>
+              </a:ext>
+            </a:extLst>
+          </p:cNvPr>
+          <p:cNvPicPr>
+            <a:picLocks noChangeAspect="1"/>
+          </p:cNvPicPr>
+          <p:nvPr/>
+        </p:nvPicPr>
+        <p:blipFill>
+          <a:blip r:embed="rId4">
+            <a:extLst>
+              <a:ext uri="{28A0092B-C50C-407E-A947-70E740481C1C}">
+                <a14:useLocalDpi xmlns:a14="http://schemas.microsoft.com/office/drawing/2010/main" val="0"/>
+              </a:ext>
+            </a:extLst>
+          </a:blip>
+          <a:stretch>
+            <a:fillRect/>
+          </a:stretch>
+        </p:blipFill>
+        <p:spPr>
+          <a:xfrm>
+            <a:off x="66676" y="3429000"/>
+            <a:ext cx="6029324" cy="3146554"/>
+          </a:xfrm>
+          <a:prstGeom prst="rect">
+            <a:avLst/>
+          </a:prstGeom>
+        </p:spPr>
+      </p:pic>
+      <p:pic>
+        <p:nvPicPr>
+          <p:cNvPr id="15" name="圖片 14" descr="一張含有 文字, 螢幕擷取畫面, 行, 圖表 的圖片&#10;&#10;AI 產生的內容可能不正確。">
+            <a:extLst>
+              <a:ext uri="{FF2B5EF4-FFF2-40B4-BE49-F238E27FC236}">
+                <a16:creationId xmlns:a16="http://schemas.microsoft.com/office/drawing/2014/main" id="{AFE6E551-1031-1BA1-24A2-5E45EE615500}"/>
+              </a:ext>
+            </a:extLst>
+          </p:cNvPr>
+          <p:cNvPicPr>
+            <a:picLocks noChangeAspect="1"/>
+          </p:cNvPicPr>
+          <p:nvPr/>
+        </p:nvPicPr>
+        <p:blipFill>
+          <a:blip r:embed="rId5">
+            <a:extLst>
+              <a:ext uri="{28A0092B-C50C-407E-A947-70E740481C1C}">
+                <a14:useLocalDpi xmlns:a14="http://schemas.microsoft.com/office/drawing/2010/main" val="0"/>
+              </a:ext>
+            </a:extLst>
+          </a:blip>
+          <a:stretch>
+            <a:fillRect/>
+          </a:stretch>
+        </p:blipFill>
+        <p:spPr>
+          <a:xfrm>
+            <a:off x="6096000" y="3429000"/>
+            <a:ext cx="6029324" cy="3146554"/>
+          </a:xfrm>
+          <a:prstGeom prst="rect">
+            <a:avLst/>
+          </a:prstGeom>
+        </p:spPr>
+      </p:pic>
+      <p:sp>
+        <p:nvSpPr>
+          <p:cNvPr id="2" name="標題 1">
+            <a:extLst>
+              <a:ext uri="{FF2B5EF4-FFF2-40B4-BE49-F238E27FC236}">
+                <a16:creationId xmlns:a16="http://schemas.microsoft.com/office/drawing/2014/main" id="{4142532F-671E-102C-B799-2CCB467C587D}"/>
+              </a:ext>
+            </a:extLst>
+          </p:cNvPr>
+          <p:cNvSpPr>
+            <a:spLocks noGrp="1"/>
+          </p:cNvSpPr>
+          <p:nvPr>
+            <p:ph type="title"/>
+          </p:nvPr>
+        </p:nvSpPr>
+        <p:spPr>
+          <a:xfrm>
+            <a:off x="11096897" y="0"/>
+            <a:ext cx="1095103" cy="662486"/>
+          </a:xfrm>
+        </p:spPr>
+        <p:txBody>
+          <a:bodyPr>
+            <a:normAutofit fontScale="90000"/>
+          </a:bodyPr>
+          <a:lstStyle/>
+          <a:p>
+            <a:r>
+              <a:rPr lang="en-US" altLang="zh-TW" dirty="0">
+                <a:latin typeface="Times New Roman" panose="02020603050405020304" pitchFamily="18" charset="0"/>
+                <a:cs typeface="Times New Roman" panose="02020603050405020304" pitchFamily="18" charset="0"/>
+              </a:rPr>
+              <a:t>9/30</a:t>
+            </a:r>
+            <a:endParaRPr lang="zh-TW" altLang="en-US" dirty="0">
+              <a:latin typeface="Times New Roman" panose="02020603050405020304" pitchFamily="18" charset="0"/>
+              <a:cs typeface="Times New Roman" panose="02020603050405020304" pitchFamily="18" charset="0"/>
+            </a:endParaRPr>
+          </a:p>
+        </p:txBody>
+      </p:sp>
+    </p:spTree>
+    <p:extLst>
+      <p:ext uri="{BB962C8B-B14F-4D97-AF65-F5344CB8AC3E}">
+        <p14:creationId xmlns:p14="http://schemas.microsoft.com/office/powerpoint/2010/main" val="3149724522"/>
+      </p:ext>
+    </p:extLst>
+  </p:cSld>
+  <p:clrMapOvr>
+    <a:masterClrMapping/>
+  </p:clrMapOvr>
+</p:sld>
+</file>
+
+<file path=ppt/slides/slide5.xml><?xml version="1.0" encoding="utf-8"?>
+<p:sld xmlns:a="http://schemas.openxmlformats.org/drawingml/2006/main" xmlns:r="http://schemas.openxmlformats.org/officeDocument/2006/relationships" xmlns:p="http://schemas.openxmlformats.org/presentationml/2006/main">
+  <p:cSld>
+    <p:spTree>
+      <p:nvGrpSpPr>
+        <p:cNvPr id="1" name="">
+          <a:extLst>
+            <a:ext uri="{FF2B5EF4-FFF2-40B4-BE49-F238E27FC236}">
+              <a16:creationId xmlns:a16="http://schemas.microsoft.com/office/drawing/2014/main" id="{78A540E3-A324-F76C-2EC3-B2748C428354}"/>
+            </a:ext>
+          </a:extLst>
+        </p:cNvPr>
+        <p:cNvGrpSpPr/>
+        <p:nvPr/>
+      </p:nvGrpSpPr>
+      <p:grpSpPr>
+        <a:xfrm>
+          <a:off x="0" y="0"/>
+          <a:ext cx="0" cy="0"/>
+          <a:chOff x="0" y="0"/>
+          <a:chExt cx="0" cy="0"/>
+        </a:xfrm>
+      </p:grpSpPr>
+      <p:sp>
+        <p:nvSpPr>
+          <p:cNvPr id="6" name="文字方塊 5">
+            <a:extLst>
+              <a:ext uri="{FF2B5EF4-FFF2-40B4-BE49-F238E27FC236}">
+                <a16:creationId xmlns:a16="http://schemas.microsoft.com/office/drawing/2014/main" id="{4947B661-201E-343D-9A40-63D1D872EAB0}"/>
+              </a:ext>
+            </a:extLst>
+          </p:cNvPr>
+          <p:cNvSpPr txBox="1"/>
+          <p:nvPr/>
+        </p:nvSpPr>
+        <p:spPr>
+          <a:xfrm>
+            <a:off x="857251" y="343499"/>
+            <a:ext cx="9191624" cy="707886"/>
+          </a:xfrm>
+          <a:prstGeom prst="rect">
+            <a:avLst/>
+          </a:prstGeom>
+          <a:noFill/>
+        </p:spPr>
+        <p:txBody>
+          <a:bodyPr wrap="square" rtlCol="0">
+            <a:spAutoFit/>
+          </a:bodyPr>
+          <a:lstStyle/>
+          <a:p>
+            <a:r>
+              <a:rPr lang="en-US" altLang="zh-TW" sz="4000" dirty="0">
+                <a:latin typeface="Times New Roman" panose="02020603050405020304" pitchFamily="18" charset="0"/>
+                <a:cs typeface="Times New Roman" panose="02020603050405020304" pitchFamily="18" charset="0"/>
+              </a:rPr>
+              <a:t>Fitting with Phase-Offset-Removed Data</a:t>
+            </a:r>
+          </a:p>
+        </p:txBody>
+      </p:sp>
+      <p:pic>
+        <p:nvPicPr>
+          <p:cNvPr id="3" name="圖片 2">
+            <a:extLst>
+              <a:ext uri="{FF2B5EF4-FFF2-40B4-BE49-F238E27FC236}">
+                <a16:creationId xmlns:a16="http://schemas.microsoft.com/office/drawing/2014/main" id="{25A74F6A-2371-CDB5-2562-011E8A65F9A2}"/>
+              </a:ext>
+            </a:extLst>
+          </p:cNvPr>
+          <p:cNvPicPr>
+            <a:picLocks noChangeAspect="1"/>
+          </p:cNvPicPr>
+          <p:nvPr/>
+        </p:nvPicPr>
+        <p:blipFill>
+          <a:blip r:embed="rId2"/>
+          <a:stretch>
+            <a:fillRect/>
+          </a:stretch>
+        </p:blipFill>
+        <p:spPr>
+          <a:xfrm>
+            <a:off x="2306937" y="1447512"/>
+            <a:ext cx="7578126" cy="4324637"/>
+          </a:xfrm>
+          <a:prstGeom prst="rect">
+            <a:avLst/>
+          </a:prstGeom>
+        </p:spPr>
+      </p:pic>
+      <p:sp>
+        <p:nvSpPr>
+          <p:cNvPr id="2" name="標題 1">
+            <a:extLst>
+              <a:ext uri="{FF2B5EF4-FFF2-40B4-BE49-F238E27FC236}">
+                <a16:creationId xmlns:a16="http://schemas.microsoft.com/office/drawing/2014/main" id="{9AE23EA7-B773-4F31-072D-5ABE9DAE842D}"/>
+              </a:ext>
+            </a:extLst>
+          </p:cNvPr>
+          <p:cNvSpPr txBox="1">
+            <a:spLocks/>
+          </p:cNvSpPr>
+          <p:nvPr/>
+        </p:nvSpPr>
+        <p:spPr>
+          <a:xfrm>
+            <a:off x="11096897" y="0"/>
+            <a:ext cx="1095103" cy="662486"/>
+          </a:xfrm>
+          <a:prstGeom prst="rect">
+            <a:avLst/>
+          </a:prstGeom>
+        </p:spPr>
+        <p:txBody>
+          <a:bodyPr vert="horz" lIns="91440" tIns="45720" rIns="91440" bIns="45720" rtlCol="0" anchor="b">
+            <a:normAutofit fontScale="60000" lnSpcReduction="20000"/>
+          </a:bodyPr>
+          <a:lstStyle>
+            <a:lvl1pPr algn="ctr" defTabSz="914400" rtl="0" eaLnBrk="1" latinLnBrk="0" hangingPunct="1">
+              <a:lnSpc>
+                <a:spcPct val="90000"/>
+              </a:lnSpc>
+              <a:spcBef>
+                <a:spcPct val="0"/>
+              </a:spcBef>
+              <a:buNone/>
+              <a:defRPr sz="6000" kern="1200">
+                <a:solidFill>
+                  <a:schemeClr val="tx1"/>
+                </a:solidFill>
+                <a:latin typeface="+mj-lt"/>
+                <a:ea typeface="+mj-ea"/>
+                <a:cs typeface="+mj-cs"/>
+              </a:defRPr>
+            </a:lvl1pPr>
+          </a:lstStyle>
+          <a:p>
+            <a:r>
+              <a:rPr lang="en-US" altLang="zh-TW">
+                <a:latin typeface="Times New Roman" panose="02020603050405020304" pitchFamily="18" charset="0"/>
+                <a:cs typeface="Times New Roman" panose="02020603050405020304" pitchFamily="18" charset="0"/>
+              </a:rPr>
+              <a:t>9/30</a:t>
+            </a:r>
+            <a:endParaRPr lang="zh-TW" altLang="en-US" dirty="0">
+              <a:latin typeface="Times New Roman" panose="02020603050405020304" pitchFamily="18" charset="0"/>
+              <a:cs typeface="Times New Roman" panose="02020603050405020304" pitchFamily="18" charset="0"/>
+            </a:endParaRPr>
+          </a:p>
+        </p:txBody>
+      </p:sp>
+    </p:spTree>
+    <p:extLst>
+      <p:ext uri="{BB962C8B-B14F-4D97-AF65-F5344CB8AC3E}">
+        <p14:creationId xmlns:p14="http://schemas.microsoft.com/office/powerpoint/2010/main" val="2985807874"/>
+      </p:ext>
+    </p:extLst>
+  </p:cSld>
+  <p:clrMapOvr>
+    <a:masterClrMapping/>
+  </p:clrMapOvr>
+</p:sld>
+</file>
+
+<file path=ppt/slides/slide6.xml><?xml version="1.0" encoding="utf-8"?>
+<p:sld xmlns:a="http://schemas.openxmlformats.org/drawingml/2006/main" xmlns:r="http://schemas.openxmlformats.org/officeDocument/2006/relationships" xmlns:p="http://schemas.openxmlformats.org/presentationml/2006/main">
+  <p:cSld>
+    <p:spTree>
+      <p:nvGrpSpPr>
+        <p:cNvPr id="1" name=""/>
+        <p:cNvGrpSpPr/>
+        <p:nvPr/>
+      </p:nvGrpSpPr>
+      <p:grpSpPr>
+        <a:xfrm>
+          <a:off x="0" y="0"/>
+          <a:ext cx="0" cy="0"/>
+          <a:chOff x="0" y="0"/>
+          <a:chExt cx="0" cy="0"/>
+        </a:xfrm>
+      </p:grpSpPr>
+      <p:pic>
+        <p:nvPicPr>
+          <p:cNvPr id="4" name="圖片 3" descr="一張含有 文字, 圖表, 行, 繪圖 的圖片&#10;&#10;AI 產生的內容可能不正確。">
+            <a:extLst>
+              <a:ext uri="{FF2B5EF4-FFF2-40B4-BE49-F238E27FC236}">
+                <a16:creationId xmlns:a16="http://schemas.microsoft.com/office/drawing/2014/main" id="{BD0ED5AB-933D-FF2B-BBD3-78561D289F8F}"/>
+              </a:ext>
+            </a:extLst>
+          </p:cNvPr>
+          <p:cNvPicPr>
+            <a:picLocks noChangeAspect="1"/>
+          </p:cNvPicPr>
+          <p:nvPr/>
+        </p:nvPicPr>
+        <p:blipFill>
+          <a:blip r:embed="rId2">
+            <a:extLst>
+              <a:ext uri="{28A0092B-C50C-407E-A947-70E740481C1C}">
+                <a14:useLocalDpi xmlns:a14="http://schemas.microsoft.com/office/drawing/2010/main" val="0"/>
+              </a:ext>
+            </a:extLst>
+          </a:blip>
+          <a:stretch>
+            <a:fillRect/>
+          </a:stretch>
+        </p:blipFill>
+        <p:spPr>
+          <a:xfrm>
+            <a:off x="171450" y="2533650"/>
+            <a:ext cx="6096000" cy="3048000"/>
+          </a:xfrm>
+          <a:prstGeom prst="rect">
+            <a:avLst/>
+          </a:prstGeom>
+        </p:spPr>
+      </p:pic>
+      <p:pic>
+        <p:nvPicPr>
+          <p:cNvPr id="5" name="圖片 4" descr="一張含有 文字, 圖表, 行, 繪圖 的圖片&#10;&#10;AI 產生的內容可能不正確。">
+            <a:extLst>
+              <a:ext uri="{FF2B5EF4-FFF2-40B4-BE49-F238E27FC236}">
+                <a16:creationId xmlns:a16="http://schemas.microsoft.com/office/drawing/2014/main" id="{61B53945-A255-87A5-7555-4CA334C137AE}"/>
+              </a:ext>
+            </a:extLst>
+          </p:cNvPr>
+          <p:cNvPicPr>
+            <a:picLocks noChangeAspect="1"/>
+          </p:cNvPicPr>
+          <p:nvPr/>
+        </p:nvPicPr>
+        <p:blipFill>
+          <a:blip r:embed="rId3">
+            <a:extLst>
+              <a:ext uri="{28A0092B-C50C-407E-A947-70E740481C1C}">
+                <a14:useLocalDpi xmlns:a14="http://schemas.microsoft.com/office/drawing/2010/main" val="0"/>
+              </a:ext>
+            </a:extLst>
+          </a:blip>
+          <a:stretch>
+            <a:fillRect/>
+          </a:stretch>
+        </p:blipFill>
+        <p:spPr>
+          <a:xfrm>
+            <a:off x="6096000" y="2533650"/>
+            <a:ext cx="6096000" cy="3048000"/>
+          </a:xfrm>
+          <a:prstGeom prst="rect">
+            <a:avLst/>
+          </a:prstGeom>
+        </p:spPr>
+      </p:pic>
+      <p:sp>
+        <p:nvSpPr>
+          <p:cNvPr id="6" name="文字方塊 5">
+            <a:extLst>
+              <a:ext uri="{FF2B5EF4-FFF2-40B4-BE49-F238E27FC236}">
+                <a16:creationId xmlns:a16="http://schemas.microsoft.com/office/drawing/2014/main" id="{0A7EF699-5A81-8948-5B1C-7549C51C21D7}"/>
+              </a:ext>
+            </a:extLst>
+          </p:cNvPr>
+          <p:cNvSpPr txBox="1"/>
+          <p:nvPr/>
+        </p:nvSpPr>
+        <p:spPr>
+          <a:xfrm>
+            <a:off x="857251" y="810224"/>
+            <a:ext cx="4438649" cy="707886"/>
+          </a:xfrm>
+          <a:prstGeom prst="rect">
+            <a:avLst/>
+          </a:prstGeom>
+          <a:noFill/>
+        </p:spPr>
+        <p:txBody>
+          <a:bodyPr wrap="square" rtlCol="0">
+            <a:spAutoFit/>
+          </a:bodyPr>
+          <a:lstStyle/>
+          <a:p>
+            <a:r>
+              <a:rPr lang="en-US" altLang="zh-TW" sz="4000" dirty="0">
+                <a:latin typeface="Times New Roman" panose="02020603050405020304" pitchFamily="18" charset="0"/>
+                <a:cs typeface="Times New Roman" panose="02020603050405020304" pitchFamily="18" charset="0"/>
+              </a:rPr>
+              <a:t>Comparison Results</a:t>
+            </a:r>
+          </a:p>
+        </p:txBody>
+      </p:sp>
+      <p:sp>
+        <p:nvSpPr>
+          <p:cNvPr id="2" name="標題 1">
+            <a:extLst>
+              <a:ext uri="{FF2B5EF4-FFF2-40B4-BE49-F238E27FC236}">
+                <a16:creationId xmlns:a16="http://schemas.microsoft.com/office/drawing/2014/main" id="{A5D035A3-C72D-1EC6-F9BB-7A4FA08805C3}"/>
+              </a:ext>
+            </a:extLst>
+          </p:cNvPr>
+          <p:cNvSpPr>
+            <a:spLocks noGrp="1"/>
+          </p:cNvSpPr>
+          <p:nvPr>
+            <p:ph type="title"/>
+          </p:nvPr>
+        </p:nvSpPr>
+        <p:spPr>
+          <a:xfrm>
+            <a:off x="11096897" y="0"/>
+            <a:ext cx="1095103" cy="662486"/>
+          </a:xfrm>
+        </p:spPr>
+        <p:txBody>
+          <a:bodyPr>
+            <a:normAutofit fontScale="90000"/>
+          </a:bodyPr>
+          <a:lstStyle/>
+          <a:p>
+            <a:r>
+              <a:rPr lang="en-US" altLang="zh-TW" dirty="0">
+                <a:latin typeface="Times New Roman" panose="02020603050405020304" pitchFamily="18" charset="0"/>
+                <a:cs typeface="Times New Roman" panose="02020603050405020304" pitchFamily="18" charset="0"/>
+              </a:rPr>
+              <a:t>9/30</a:t>
+            </a:r>
+            <a:endParaRPr lang="zh-TW" altLang="en-US" dirty="0">
+              <a:latin typeface="Times New Roman" panose="02020603050405020304" pitchFamily="18" charset="0"/>
+              <a:cs typeface="Times New Roman" panose="02020603050405020304" pitchFamily="18" charset="0"/>
+            </a:endParaRPr>
+          </a:p>
+        </p:txBody>
+      </p:sp>
+    </p:spTree>
+    <p:extLst>
+      <p:ext uri="{BB962C8B-B14F-4D97-AF65-F5344CB8AC3E}">
+        <p14:creationId xmlns:p14="http://schemas.microsoft.com/office/powerpoint/2010/main" val="1549243866"/>
+      </p:ext>
+    </p:extLst>
+  </p:cSld>
+  <p:clrMapOvr>
+    <a:masterClrMapping/>
+  </p:clrMapOvr>
+</p:sld>
+</file>
+
+<file path=ppt/slides/slide7.xml><?xml version="1.0" encoding="utf-8"?>
+<p:sld xmlns:a="http://schemas.openxmlformats.org/drawingml/2006/main" xmlns:r="http://schemas.openxmlformats.org/officeDocument/2006/relationships" xmlns:p="http://schemas.openxmlformats.org/presentationml/2006/main">
+  <p:cSld>
+    <p:spTree>
+      <p:nvGrpSpPr>
+        <p:cNvPr id="1" name="">
+          <a:extLst>
+            <a:ext uri="{FF2B5EF4-FFF2-40B4-BE49-F238E27FC236}">
+              <a16:creationId xmlns:a16="http://schemas.microsoft.com/office/drawing/2014/main" id="{3857742A-5285-C12C-15C2-75C7854EFDD6}"/>
+            </a:ext>
+          </a:extLst>
+        </p:cNvPr>
+        <p:cNvGrpSpPr/>
+        <p:nvPr/>
+      </p:nvGrpSpPr>
+      <p:grpSpPr>
+        <a:xfrm>
+          <a:off x="0" y="0"/>
+          <a:ext cx="0" cy="0"/>
+          <a:chOff x="0" y="0"/>
+          <a:chExt cx="0" cy="0"/>
+        </a:xfrm>
+      </p:grpSpPr>
+      <p:pic>
+        <p:nvPicPr>
+          <p:cNvPr id="4" name="圖片 3" descr="一張含有 文字, 圖表, 行, 繪圖 的圖片&#10;&#10;AI 產生的內容可能不正確。">
+            <a:extLst>
+              <a:ext uri="{FF2B5EF4-FFF2-40B4-BE49-F238E27FC236}">
+                <a16:creationId xmlns:a16="http://schemas.microsoft.com/office/drawing/2014/main" id="{401E473E-B890-FC1A-6BF5-37DB43CD6848}"/>
+              </a:ext>
+            </a:extLst>
+          </p:cNvPr>
+          <p:cNvPicPr>
+            <a:picLocks noChangeAspect="1"/>
+          </p:cNvPicPr>
+          <p:nvPr/>
+        </p:nvPicPr>
+        <p:blipFill>
+          <a:blip r:embed="rId2">
+            <a:extLst>
+              <a:ext uri="{28A0092B-C50C-407E-A947-70E740481C1C}">
+                <a14:useLocalDpi xmlns:a14="http://schemas.microsoft.com/office/drawing/2010/main" val="0"/>
+              </a:ext>
+            </a:extLst>
+          </a:blip>
+          <a:stretch>
+            <a:fillRect/>
+          </a:stretch>
+        </p:blipFill>
+        <p:spPr>
+          <a:xfrm>
+            <a:off x="6257925" y="3552825"/>
+            <a:ext cx="6096000" cy="3048000"/>
+          </a:xfrm>
+          <a:prstGeom prst="rect">
+            <a:avLst/>
+          </a:prstGeom>
+        </p:spPr>
+      </p:pic>
+      <p:pic>
+        <p:nvPicPr>
+          <p:cNvPr id="11" name="圖片 10" descr="一張含有 文字, 圖表, 行, 方案 的圖片&#10;&#10;AI 產生的內容可能不正確。">
+            <a:extLst>
+              <a:ext uri="{FF2B5EF4-FFF2-40B4-BE49-F238E27FC236}">
+                <a16:creationId xmlns:a16="http://schemas.microsoft.com/office/drawing/2014/main" id="{EBFB32DF-EABB-F413-8529-5E1BAB7AB0D6}"/>
+              </a:ext>
+            </a:extLst>
+          </p:cNvPr>
+          <p:cNvPicPr>
+            <a:picLocks noChangeAspect="1"/>
+          </p:cNvPicPr>
+          <p:nvPr/>
+        </p:nvPicPr>
+        <p:blipFill>
+          <a:blip r:embed="rId3">
+            <a:extLst>
+              <a:ext uri="{28A0092B-C50C-407E-A947-70E740481C1C}">
+                <a14:useLocalDpi xmlns:a14="http://schemas.microsoft.com/office/drawing/2010/main" val="0"/>
+              </a:ext>
+            </a:extLst>
+          </a:blip>
+          <a:stretch>
+            <a:fillRect/>
+          </a:stretch>
+        </p:blipFill>
+        <p:spPr>
+          <a:xfrm>
+            <a:off x="6257925" y="381000"/>
+            <a:ext cx="6096000" cy="3048000"/>
+          </a:xfrm>
+          <a:prstGeom prst="rect">
+            <a:avLst/>
+          </a:prstGeom>
+        </p:spPr>
+      </p:pic>
+      <p:pic>
+        <p:nvPicPr>
+          <p:cNvPr id="13" name="圖片 12" descr="一張含有 文字, 圖表, 行, 繪圖 的圖片&#10;&#10;AI 產生的內容可能不正確。">
+            <a:extLst>
+              <a:ext uri="{FF2B5EF4-FFF2-40B4-BE49-F238E27FC236}">
+                <a16:creationId xmlns:a16="http://schemas.microsoft.com/office/drawing/2014/main" id="{22F0A6BF-BF02-E895-5276-4A6D3D60A056}"/>
+              </a:ext>
+            </a:extLst>
+          </p:cNvPr>
+          <p:cNvPicPr>
+            <a:picLocks noChangeAspect="1"/>
+          </p:cNvPicPr>
+          <p:nvPr/>
+        </p:nvPicPr>
+        <p:blipFill>
+          <a:blip r:embed="rId4">
+            <a:extLst>
+              <a:ext uri="{28A0092B-C50C-407E-A947-70E740481C1C}">
+                <a14:useLocalDpi xmlns:a14="http://schemas.microsoft.com/office/drawing/2010/main" val="0"/>
+              </a:ext>
+            </a:extLst>
+          </a:blip>
+          <a:stretch>
+            <a:fillRect/>
+          </a:stretch>
+        </p:blipFill>
+        <p:spPr>
+          <a:xfrm>
+            <a:off x="295275" y="381000"/>
+            <a:ext cx="6096000" cy="3048000"/>
+          </a:xfrm>
+          <a:prstGeom prst="rect">
+            <a:avLst/>
+          </a:prstGeom>
+        </p:spPr>
+      </p:pic>
+      <p:pic>
+        <p:nvPicPr>
+          <p:cNvPr id="15" name="圖片 14" descr="一張含有 文字, 圖表, 行, 繪圖 的圖片&#10;&#10;AI 產生的內容可能不正確。">
+            <a:extLst>
+              <a:ext uri="{FF2B5EF4-FFF2-40B4-BE49-F238E27FC236}">
+                <a16:creationId xmlns:a16="http://schemas.microsoft.com/office/drawing/2014/main" id="{AF991C54-FF4B-C025-6A86-203450C334A4}"/>
+              </a:ext>
+            </a:extLst>
+          </p:cNvPr>
+          <p:cNvPicPr>
+            <a:picLocks noChangeAspect="1"/>
+          </p:cNvPicPr>
+          <p:nvPr/>
+        </p:nvPicPr>
+        <p:blipFill>
+          <a:blip r:embed="rId5">
+            <a:extLst>
+              <a:ext uri="{28A0092B-C50C-407E-A947-70E740481C1C}">
+                <a14:useLocalDpi xmlns:a14="http://schemas.microsoft.com/office/drawing/2010/main" val="0"/>
+              </a:ext>
+            </a:extLst>
+          </a:blip>
+          <a:stretch>
+            <a:fillRect/>
+          </a:stretch>
+        </p:blipFill>
+        <p:spPr>
+          <a:xfrm>
+            <a:off x="295275" y="3676650"/>
+            <a:ext cx="6096000" cy="3048000"/>
+          </a:xfrm>
+          <a:prstGeom prst="rect">
+            <a:avLst/>
+          </a:prstGeom>
+        </p:spPr>
+      </p:pic>
+      <p:sp>
+        <p:nvSpPr>
+          <p:cNvPr id="2" name="標題 1">
+            <a:extLst>
+              <a:ext uri="{FF2B5EF4-FFF2-40B4-BE49-F238E27FC236}">
+                <a16:creationId xmlns:a16="http://schemas.microsoft.com/office/drawing/2014/main" id="{2ACC0E4E-6778-37D8-4D34-DE69363282A1}"/>
+              </a:ext>
+            </a:extLst>
+          </p:cNvPr>
+          <p:cNvSpPr txBox="1">
+            <a:spLocks/>
+          </p:cNvSpPr>
+          <p:nvPr/>
+        </p:nvSpPr>
+        <p:spPr>
+          <a:xfrm>
+            <a:off x="11096897" y="0"/>
+            <a:ext cx="1095103" cy="662486"/>
+          </a:xfrm>
+          <a:prstGeom prst="rect">
+            <a:avLst/>
+          </a:prstGeom>
+        </p:spPr>
+        <p:txBody>
+          <a:bodyPr vert="horz" lIns="91440" tIns="45720" rIns="91440" bIns="45720" rtlCol="0" anchor="b">
+            <a:normAutofit fontScale="60000" lnSpcReduction="20000"/>
+          </a:bodyPr>
+          <a:lstStyle>
+            <a:lvl1pPr algn="ctr" defTabSz="914400" rtl="0" eaLnBrk="1" latinLnBrk="0" hangingPunct="1">
+              <a:lnSpc>
+                <a:spcPct val="90000"/>
+              </a:lnSpc>
+              <a:spcBef>
+                <a:spcPct val="0"/>
+              </a:spcBef>
+              <a:buNone/>
+              <a:defRPr sz="6000" kern="1200">
+                <a:solidFill>
+                  <a:schemeClr val="tx1"/>
+                </a:solidFill>
+                <a:latin typeface="+mj-lt"/>
+                <a:ea typeface="+mj-ea"/>
+                <a:cs typeface="+mj-cs"/>
+              </a:defRPr>
+            </a:lvl1pPr>
+          </a:lstStyle>
+          <a:p>
+            <a:r>
+              <a:rPr lang="en-US" altLang="zh-TW">
+                <a:latin typeface="Times New Roman" panose="02020603050405020304" pitchFamily="18" charset="0"/>
+                <a:cs typeface="Times New Roman" panose="02020603050405020304" pitchFamily="18" charset="0"/>
+              </a:rPr>
+              <a:t>9/30</a:t>
+            </a:r>
+            <a:endParaRPr lang="zh-TW" altLang="en-US" dirty="0">
+              <a:latin typeface="Times New Roman" panose="02020603050405020304" pitchFamily="18" charset="0"/>
+              <a:cs typeface="Times New Roman" panose="02020603050405020304" pitchFamily="18" charset="0"/>
+            </a:endParaRPr>
+          </a:p>
+        </p:txBody>
+      </p:sp>
+    </p:spTree>
+    <p:extLst>
+      <p:ext uri="{BB962C8B-B14F-4D97-AF65-F5344CB8AC3E}">
+        <p14:creationId xmlns:p14="http://schemas.microsoft.com/office/powerpoint/2010/main" val="2686757437"/>
+      </p:ext>
+    </p:extLst>
+  </p:cSld>
+  <p:clrMapOvr>
+    <a:masterClrMapping/>
+  </p:clrMapOvr>
+</p:sld>
+</file>
+
+<file path=ppt/slides/slide8.xml><?xml version="1.0" encoding="utf-8"?>
 <p:sld xmlns:a="http://schemas.openxmlformats.org/drawingml/2006/main" xmlns:r="http://schemas.openxmlformats.org/officeDocument/2006/relationships" xmlns:p="http://schemas.openxmlformats.org/presentationml/2006/main">
   <p:cSld>
     <p:spTree>
@@ -6278,1152 +8138,52 @@
           </mc:Fallback>
         </mc:AlternateContent>
       </p:grpSp>
-    </p:spTree>
-    <p:extLst>
-      <p:ext uri="{BB962C8B-B14F-4D97-AF65-F5344CB8AC3E}">
-        <p14:creationId xmlns:p14="http://schemas.microsoft.com/office/powerpoint/2010/main" val="144192149"/>
-      </p:ext>
-    </p:extLst>
-  </p:cSld>
-  <p:clrMapOvr>
-    <a:masterClrMapping/>
-  </p:clrMapOvr>
-</p:sld>
-</file>
-
-<file path=ppt/slides/slide11.xml><?xml version="1.0" encoding="utf-8"?>
-<p:sld xmlns:a="http://schemas.openxmlformats.org/drawingml/2006/main" xmlns:r="http://schemas.openxmlformats.org/officeDocument/2006/relationships" xmlns:p="http://schemas.openxmlformats.org/presentationml/2006/main">
-  <p:cSld>
-    <p:spTree>
-      <p:nvGrpSpPr>
-        <p:cNvPr id="1" name=""/>
-        <p:cNvGrpSpPr/>
-        <p:nvPr/>
-      </p:nvGrpSpPr>
-      <p:grpSpPr>
-        <a:xfrm>
-          <a:off x="0" y="0"/>
-          <a:ext cx="0" cy="0"/>
-          <a:chOff x="0" y="0"/>
-          <a:chExt cx="0" cy="0"/>
-        </a:xfrm>
-      </p:grpSpPr>
-      <p:pic>
-        <p:nvPicPr>
-          <p:cNvPr id="13" name="圖片 12" descr="一張含有 文字, 螢幕擷取畫面, 圖表, 行 的圖片&#10;&#10;AI 產生的內容可能不正確。">
-            <a:extLst>
-              <a:ext uri="{FF2B5EF4-FFF2-40B4-BE49-F238E27FC236}">
-                <a16:creationId xmlns:a16="http://schemas.microsoft.com/office/drawing/2014/main" id="{7D0C073B-DD88-BE84-9F4B-9920469D8007}"/>
-              </a:ext>
-            </a:extLst>
-          </p:cNvPr>
-          <p:cNvPicPr>
-            <a:picLocks noChangeAspect="1"/>
-          </p:cNvPicPr>
-          <p:nvPr/>
-        </p:nvPicPr>
-        <p:blipFill>
-          <a:blip r:embed="rId2">
-            <a:extLst>
-              <a:ext uri="{28A0092B-C50C-407E-A947-70E740481C1C}">
-                <a14:useLocalDpi xmlns:a14="http://schemas.microsoft.com/office/drawing/2010/main" val="0"/>
-              </a:ext>
-            </a:extLst>
-          </a:blip>
-          <a:stretch>
-            <a:fillRect/>
-          </a:stretch>
-        </p:blipFill>
-        <p:spPr>
-          <a:xfrm>
-            <a:off x="6205091" y="800100"/>
-            <a:ext cx="5903218" cy="5257800"/>
-          </a:xfrm>
-          <a:prstGeom prst="rect">
-            <a:avLst/>
-          </a:prstGeom>
-        </p:spPr>
-      </p:pic>
-      <p:pic>
-        <p:nvPicPr>
-          <p:cNvPr id="15" name="圖片 14" descr="一張含有 文字, 螢幕擷取畫面, 圖表, 行 的圖片&#10;&#10;AI 產生的內容可能不正確。">
-            <a:extLst>
-              <a:ext uri="{FF2B5EF4-FFF2-40B4-BE49-F238E27FC236}">
-                <a16:creationId xmlns:a16="http://schemas.microsoft.com/office/drawing/2014/main" id="{D0AB2032-110F-187A-D97F-ADC8639C8FBB}"/>
-              </a:ext>
-            </a:extLst>
-          </p:cNvPr>
-          <p:cNvPicPr>
-            <a:picLocks noChangeAspect="1"/>
-          </p:cNvPicPr>
-          <p:nvPr/>
-        </p:nvPicPr>
-        <p:blipFill>
-          <a:blip r:embed="rId3">
-            <a:extLst>
-              <a:ext uri="{28A0092B-C50C-407E-A947-70E740481C1C}">
-                <a14:useLocalDpi xmlns:a14="http://schemas.microsoft.com/office/drawing/2010/main" val="0"/>
-              </a:ext>
-            </a:extLst>
-          </a:blip>
-          <a:stretch>
-            <a:fillRect/>
-          </a:stretch>
-        </p:blipFill>
-        <p:spPr>
-          <a:xfrm>
-            <a:off x="192782" y="800100"/>
-            <a:ext cx="5903218" cy="5257800"/>
-          </a:xfrm>
-          <a:prstGeom prst="rect">
-            <a:avLst/>
-          </a:prstGeom>
-        </p:spPr>
-      </p:pic>
-    </p:spTree>
-    <p:extLst>
-      <p:ext uri="{BB962C8B-B14F-4D97-AF65-F5344CB8AC3E}">
-        <p14:creationId xmlns:p14="http://schemas.microsoft.com/office/powerpoint/2010/main" val="2990117587"/>
-      </p:ext>
-    </p:extLst>
-  </p:cSld>
-  <p:clrMapOvr>
-    <a:masterClrMapping/>
-  </p:clrMapOvr>
-</p:sld>
-</file>
-
-<file path=ppt/slides/slide12.xml><?xml version="1.0" encoding="utf-8"?>
-<p:sld xmlns:a="http://schemas.openxmlformats.org/drawingml/2006/main" xmlns:r="http://schemas.openxmlformats.org/officeDocument/2006/relationships" xmlns:p="http://schemas.openxmlformats.org/presentationml/2006/main">
-  <p:cSld>
-    <p:spTree>
-      <p:nvGrpSpPr>
-        <p:cNvPr id="1" name=""/>
-        <p:cNvGrpSpPr/>
-        <p:nvPr/>
-      </p:nvGrpSpPr>
-      <p:grpSpPr>
-        <a:xfrm>
-          <a:off x="0" y="0"/>
-          <a:ext cx="0" cy="0"/>
-          <a:chOff x="0" y="0"/>
-          <a:chExt cx="0" cy="0"/>
-        </a:xfrm>
-      </p:grpSpPr>
-      <p:pic>
-        <p:nvPicPr>
-          <p:cNvPr id="5" name="圖片 4" descr="一張含有 文字, 螢幕擷取畫面, 圖表, 行 的圖片&#10;&#10;AI 產生的內容可能不正確。">
-            <a:extLst>
-              <a:ext uri="{FF2B5EF4-FFF2-40B4-BE49-F238E27FC236}">
-                <a16:creationId xmlns:a16="http://schemas.microsoft.com/office/drawing/2014/main" id="{2E7A5474-1EE6-854C-FEF5-0A60015924BA}"/>
-              </a:ext>
-            </a:extLst>
-          </p:cNvPr>
-          <p:cNvPicPr>
-            <a:picLocks noChangeAspect="1"/>
-          </p:cNvPicPr>
-          <p:nvPr/>
-        </p:nvPicPr>
-        <p:blipFill>
-          <a:blip r:embed="rId2">
-            <a:extLst>
-              <a:ext uri="{28A0092B-C50C-407E-A947-70E740481C1C}">
-                <a14:useLocalDpi xmlns:a14="http://schemas.microsoft.com/office/drawing/2010/main" val="0"/>
-              </a:ext>
-            </a:extLst>
-          </a:blip>
-          <a:stretch>
-            <a:fillRect/>
-          </a:stretch>
-        </p:blipFill>
-        <p:spPr>
-          <a:xfrm>
-            <a:off x="0" y="714248"/>
-            <a:ext cx="6096000" cy="5429504"/>
-          </a:xfrm>
-          <a:prstGeom prst="rect">
-            <a:avLst/>
-          </a:prstGeom>
-        </p:spPr>
-      </p:pic>
-      <p:pic>
-        <p:nvPicPr>
-          <p:cNvPr id="7" name="圖片 6" descr="一張含有 文字, 螢幕擷取畫面, 圖表, 行 的圖片&#10;&#10;AI 產生的內容可能不正確。">
-            <a:extLst>
-              <a:ext uri="{FF2B5EF4-FFF2-40B4-BE49-F238E27FC236}">
-                <a16:creationId xmlns:a16="http://schemas.microsoft.com/office/drawing/2014/main" id="{4DF2F87B-B605-34CF-9465-3BC543833D9B}"/>
-              </a:ext>
-            </a:extLst>
-          </p:cNvPr>
-          <p:cNvPicPr>
-            <a:picLocks noChangeAspect="1"/>
-          </p:cNvPicPr>
-          <p:nvPr/>
-        </p:nvPicPr>
-        <p:blipFill>
-          <a:blip r:embed="rId3">
-            <a:extLst>
-              <a:ext uri="{28A0092B-C50C-407E-A947-70E740481C1C}">
-                <a14:useLocalDpi xmlns:a14="http://schemas.microsoft.com/office/drawing/2010/main" val="0"/>
-              </a:ext>
-            </a:extLst>
-          </a:blip>
-          <a:stretch>
-            <a:fillRect/>
-          </a:stretch>
-        </p:blipFill>
-        <p:spPr>
-          <a:xfrm>
-            <a:off x="6096000" y="714248"/>
-            <a:ext cx="6096000" cy="5429504"/>
-          </a:xfrm>
-          <a:prstGeom prst="rect">
-            <a:avLst/>
-          </a:prstGeom>
-        </p:spPr>
-      </p:pic>
-    </p:spTree>
-    <p:extLst>
-      <p:ext uri="{BB962C8B-B14F-4D97-AF65-F5344CB8AC3E}">
-        <p14:creationId xmlns:p14="http://schemas.microsoft.com/office/powerpoint/2010/main" val="2088503058"/>
-      </p:ext>
-    </p:extLst>
-  </p:cSld>
-  <p:clrMapOvr>
-    <a:masterClrMapping/>
-  </p:clrMapOvr>
-</p:sld>
-</file>
-
-<file path=ppt/slides/slide2.xml><?xml version="1.0" encoding="utf-8"?>
-<p:sld xmlns:a="http://schemas.openxmlformats.org/drawingml/2006/main" xmlns:r="http://schemas.openxmlformats.org/officeDocument/2006/relationships" xmlns:p="http://schemas.openxmlformats.org/presentationml/2006/main">
-  <p:cSld>
-    <p:spTree>
-      <p:nvGrpSpPr>
-        <p:cNvPr id="1" name=""/>
-        <p:cNvGrpSpPr/>
-        <p:nvPr/>
-      </p:nvGrpSpPr>
-      <p:grpSpPr>
-        <a:xfrm>
-          <a:off x="0" y="0"/>
-          <a:ext cx="0" cy="0"/>
-          <a:chOff x="0" y="0"/>
-          <a:chExt cx="0" cy="0"/>
-        </a:xfrm>
-      </p:grpSpPr>
-      <p:pic>
-        <p:nvPicPr>
-          <p:cNvPr id="5" name="圖片 4">
-            <a:extLst>
-              <a:ext uri="{FF2B5EF4-FFF2-40B4-BE49-F238E27FC236}">
-                <a16:creationId xmlns:a16="http://schemas.microsoft.com/office/drawing/2014/main" id="{87927162-16B5-D086-B58F-9379DA7CE8AD}"/>
-              </a:ext>
-            </a:extLst>
-          </p:cNvPr>
-          <p:cNvPicPr>
-            <a:picLocks noChangeAspect="1"/>
-          </p:cNvPicPr>
-          <p:nvPr/>
-        </p:nvPicPr>
-        <p:blipFill>
-          <a:blip r:embed="rId2"/>
-          <a:stretch>
-            <a:fillRect/>
-          </a:stretch>
-        </p:blipFill>
-        <p:spPr>
-          <a:xfrm>
-            <a:off x="2064295" y="1680886"/>
-            <a:ext cx="8063409" cy="4479672"/>
-          </a:xfrm>
-          <a:prstGeom prst="rect">
-            <a:avLst/>
-          </a:prstGeom>
-        </p:spPr>
-      </p:pic>
       <p:sp>
         <p:nvSpPr>
-          <p:cNvPr id="6" name="文字方塊 5">
-            <a:extLst>
-              <a:ext uri="{FF2B5EF4-FFF2-40B4-BE49-F238E27FC236}">
-                <a16:creationId xmlns:a16="http://schemas.microsoft.com/office/drawing/2014/main" id="{2743031D-214E-AC92-DDC6-69FB539A6DD4}"/>
-              </a:ext>
-            </a:extLst>
-          </p:cNvPr>
-          <p:cNvSpPr txBox="1"/>
-          <p:nvPr/>
+          <p:cNvPr id="2" name="標題 1">
+            <a:extLst>
+              <a:ext uri="{FF2B5EF4-FFF2-40B4-BE49-F238E27FC236}">
+                <a16:creationId xmlns:a16="http://schemas.microsoft.com/office/drawing/2014/main" id="{604C1C26-042E-DFC0-45B4-EF5C43BF62DA}"/>
+              </a:ext>
+            </a:extLst>
+          </p:cNvPr>
+          <p:cNvSpPr>
+            <a:spLocks noGrp="1"/>
+          </p:cNvSpPr>
+          <p:nvPr>
+            <p:ph type="title"/>
+          </p:nvPr>
         </p:nvSpPr>
         <p:spPr>
           <a:xfrm>
-            <a:off x="857251" y="343499"/>
-            <a:ext cx="7458074" cy="707886"/>
+            <a:off x="11096897" y="0"/>
+            <a:ext cx="1095103" cy="662486"/>
           </a:xfrm>
-          <a:prstGeom prst="rect">
-            <a:avLst/>
-          </a:prstGeom>
-          <a:noFill/>
         </p:spPr>
         <p:txBody>
-          <a:bodyPr wrap="square" rtlCol="0">
-            <a:spAutoFit/>
+          <a:bodyPr>
+            <a:normAutofit fontScale="90000"/>
           </a:bodyPr>
           <a:lstStyle/>
           <a:p>
             <a:r>
-              <a:rPr lang="en-US" altLang="zh-TW" sz="4000" dirty="0">
+              <a:rPr lang="en-US" altLang="zh-TW" dirty="0">
                 <a:latin typeface="Times New Roman" panose="02020603050405020304" pitchFamily="18" charset="0"/>
                 <a:cs typeface="Times New Roman" panose="02020603050405020304" pitchFamily="18" charset="0"/>
               </a:rPr>
-              <a:t>Fitting with Original Phase Data</a:t>
+              <a:t>10/2</a:t>
             </a:r>
+            <a:endParaRPr lang="zh-TW" altLang="en-US" dirty="0">
+              <a:latin typeface="Times New Roman" panose="02020603050405020304" pitchFamily="18" charset="0"/>
+              <a:cs typeface="Times New Roman" panose="02020603050405020304" pitchFamily="18" charset="0"/>
+            </a:endParaRPr>
           </a:p>
         </p:txBody>
       </p:sp>
     </p:spTree>
     <p:extLst>
       <p:ext uri="{BB962C8B-B14F-4D97-AF65-F5344CB8AC3E}">
-        <p14:creationId xmlns:p14="http://schemas.microsoft.com/office/powerpoint/2010/main" val="1387276854"/>
-      </p:ext>
-    </p:extLst>
-  </p:cSld>
-  <p:clrMapOvr>
-    <a:masterClrMapping/>
-  </p:clrMapOvr>
-</p:sld>
-</file>
-
-<file path=ppt/slides/slide3.xml><?xml version="1.0" encoding="utf-8"?>
-<p:sld xmlns:a="http://schemas.openxmlformats.org/drawingml/2006/main" xmlns:r="http://schemas.openxmlformats.org/officeDocument/2006/relationships" xmlns:p="http://schemas.openxmlformats.org/presentationml/2006/main">
-  <p:cSld>
-    <p:spTree>
-      <p:nvGrpSpPr>
-        <p:cNvPr id="1" name=""/>
-        <p:cNvGrpSpPr/>
-        <p:nvPr/>
-      </p:nvGrpSpPr>
-      <p:grpSpPr>
-        <a:xfrm>
-          <a:off x="0" y="0"/>
-          <a:ext cx="0" cy="0"/>
-          <a:chOff x="0" y="0"/>
-          <a:chExt cx="0" cy="0"/>
-        </a:xfrm>
-      </p:grpSpPr>
-      <p:pic>
-        <p:nvPicPr>
-          <p:cNvPr id="5" name="圖片 4" descr="一張含有 文字, 圖表, 螢幕擷取畫面, 行 的圖片&#10;&#10;AI 產生的內容可能不正確。">
-            <a:extLst>
-              <a:ext uri="{FF2B5EF4-FFF2-40B4-BE49-F238E27FC236}">
-                <a16:creationId xmlns:a16="http://schemas.microsoft.com/office/drawing/2014/main" id="{76B56E03-2F13-0787-7FA0-CD08ABFE67F5}"/>
-              </a:ext>
-            </a:extLst>
-          </p:cNvPr>
-          <p:cNvPicPr>
-            <a:picLocks noChangeAspect="1"/>
-          </p:cNvPicPr>
-          <p:nvPr/>
-        </p:nvPicPr>
-        <p:blipFill>
-          <a:blip r:embed="rId2">
-            <a:extLst>
-              <a:ext uri="{28A0092B-C50C-407E-A947-70E740481C1C}">
-                <a14:useLocalDpi xmlns:a14="http://schemas.microsoft.com/office/drawing/2010/main" val="0"/>
-              </a:ext>
-            </a:extLst>
-          </a:blip>
-          <a:stretch>
-            <a:fillRect/>
-          </a:stretch>
-        </p:blipFill>
-        <p:spPr>
-          <a:xfrm>
-            <a:off x="276226" y="2123816"/>
-            <a:ext cx="6029324" cy="3146554"/>
-          </a:xfrm>
-          <a:prstGeom prst="rect">
-            <a:avLst/>
-          </a:prstGeom>
-        </p:spPr>
-      </p:pic>
-      <p:pic>
-        <p:nvPicPr>
-          <p:cNvPr id="7" name="圖片 6" descr="一張含有 文字, 圖表, 螢幕擷取畫面, 行 的圖片&#10;&#10;AI 產生的內容可能不正確。">
-            <a:extLst>
-              <a:ext uri="{FF2B5EF4-FFF2-40B4-BE49-F238E27FC236}">
-                <a16:creationId xmlns:a16="http://schemas.microsoft.com/office/drawing/2014/main" id="{0FC02AC8-796F-A093-9852-61F082A17D09}"/>
-              </a:ext>
-            </a:extLst>
-          </p:cNvPr>
-          <p:cNvPicPr>
-            <a:picLocks noChangeAspect="1"/>
-          </p:cNvPicPr>
-          <p:nvPr/>
-        </p:nvPicPr>
-        <p:blipFill>
-          <a:blip r:embed="rId3">
-            <a:extLst>
-              <a:ext uri="{28A0092B-C50C-407E-A947-70E740481C1C}">
-                <a14:useLocalDpi xmlns:a14="http://schemas.microsoft.com/office/drawing/2010/main" val="0"/>
-              </a:ext>
-            </a:extLst>
-          </a:blip>
-          <a:stretch>
-            <a:fillRect/>
-          </a:stretch>
-        </p:blipFill>
-        <p:spPr>
-          <a:xfrm>
-            <a:off x="6162676" y="2123816"/>
-            <a:ext cx="6029324" cy="3146554"/>
-          </a:xfrm>
-          <a:prstGeom prst="rect">
-            <a:avLst/>
-          </a:prstGeom>
-        </p:spPr>
-      </p:pic>
-      <p:sp>
-        <p:nvSpPr>
-          <p:cNvPr id="11" name="文字方塊 10">
-            <a:extLst>
-              <a:ext uri="{FF2B5EF4-FFF2-40B4-BE49-F238E27FC236}">
-                <a16:creationId xmlns:a16="http://schemas.microsoft.com/office/drawing/2014/main" id="{530EB3E9-62D0-DC8E-0EA6-B3F37FE245E3}"/>
-              </a:ext>
-            </a:extLst>
-          </p:cNvPr>
-          <p:cNvSpPr txBox="1"/>
-          <p:nvPr/>
-        </p:nvSpPr>
-        <p:spPr>
-          <a:xfrm>
-            <a:off x="857251" y="343499"/>
-            <a:ext cx="7458074" cy="707886"/>
-          </a:xfrm>
-          <a:prstGeom prst="rect">
-            <a:avLst/>
-          </a:prstGeom>
-          <a:noFill/>
-        </p:spPr>
-        <p:txBody>
-          <a:bodyPr wrap="square" rtlCol="0">
-            <a:spAutoFit/>
-          </a:bodyPr>
-          <a:lstStyle/>
-          <a:p>
-            <a:r>
-              <a:rPr lang="en-US" altLang="zh-TW" sz="4000" dirty="0">
-                <a:latin typeface="Times New Roman" panose="02020603050405020304" pitchFamily="18" charset="0"/>
-                <a:cs typeface="Times New Roman" panose="02020603050405020304" pitchFamily="18" charset="0"/>
-              </a:rPr>
-              <a:t>Fitting with Original Phase Data</a:t>
-            </a:r>
-          </a:p>
-        </p:txBody>
-      </p:sp>
-    </p:spTree>
-    <p:extLst>
-      <p:ext uri="{BB962C8B-B14F-4D97-AF65-F5344CB8AC3E}">
-        <p14:creationId xmlns:p14="http://schemas.microsoft.com/office/powerpoint/2010/main" val="3566969151"/>
-      </p:ext>
-    </p:extLst>
-  </p:cSld>
-  <p:clrMapOvr>
-    <a:masterClrMapping/>
-  </p:clrMapOvr>
-</p:sld>
-</file>
-
-<file path=ppt/slides/slide4.xml><?xml version="1.0" encoding="utf-8"?>
-<p:sld xmlns:a="http://schemas.openxmlformats.org/drawingml/2006/main" xmlns:r="http://schemas.openxmlformats.org/officeDocument/2006/relationships" xmlns:p="http://schemas.openxmlformats.org/presentationml/2006/main">
-  <p:cSld>
-    <p:spTree>
-      <p:nvGrpSpPr>
-        <p:cNvPr id="1" name=""/>
-        <p:cNvGrpSpPr/>
-        <p:nvPr/>
-      </p:nvGrpSpPr>
-      <p:grpSpPr>
-        <a:xfrm>
-          <a:off x="0" y="0"/>
-          <a:ext cx="0" cy="0"/>
-          <a:chOff x="0" y="0"/>
-          <a:chExt cx="0" cy="0"/>
-        </a:xfrm>
-      </p:grpSpPr>
-      <p:pic>
-        <p:nvPicPr>
-          <p:cNvPr id="9" name="圖片 8" descr="一張含有 文字, 螢幕擷取畫面, 行, 圖表 的圖片&#10;&#10;AI 產生的內容可能不正確。">
-            <a:extLst>
-              <a:ext uri="{FF2B5EF4-FFF2-40B4-BE49-F238E27FC236}">
-                <a16:creationId xmlns:a16="http://schemas.microsoft.com/office/drawing/2014/main" id="{CC9F8A7C-C7EB-13AD-14C4-45486C82BCF3}"/>
-              </a:ext>
-            </a:extLst>
-          </p:cNvPr>
-          <p:cNvPicPr>
-            <a:picLocks noChangeAspect="1"/>
-          </p:cNvPicPr>
-          <p:nvPr/>
-        </p:nvPicPr>
-        <p:blipFill>
-          <a:blip r:embed="rId2">
-            <a:extLst>
-              <a:ext uri="{28A0092B-C50C-407E-A947-70E740481C1C}">
-                <a14:useLocalDpi xmlns:a14="http://schemas.microsoft.com/office/drawing/2010/main" val="0"/>
-              </a:ext>
-            </a:extLst>
-          </a:blip>
-          <a:stretch>
-            <a:fillRect/>
-          </a:stretch>
-        </p:blipFill>
-        <p:spPr>
-          <a:xfrm>
-            <a:off x="66676" y="282446"/>
-            <a:ext cx="6029324" cy="3146554"/>
-          </a:xfrm>
-          <a:prstGeom prst="rect">
-            <a:avLst/>
-          </a:prstGeom>
-        </p:spPr>
-      </p:pic>
-      <p:pic>
-        <p:nvPicPr>
-          <p:cNvPr id="11" name="圖片 10" descr="一張含有 文字, 螢幕擷取畫面, 圖表, 行 的圖片&#10;&#10;AI 產生的內容可能不正確。">
-            <a:extLst>
-              <a:ext uri="{FF2B5EF4-FFF2-40B4-BE49-F238E27FC236}">
-                <a16:creationId xmlns:a16="http://schemas.microsoft.com/office/drawing/2014/main" id="{9705C1BC-2F92-921F-714D-577BBB25F487}"/>
-              </a:ext>
-            </a:extLst>
-          </p:cNvPr>
-          <p:cNvPicPr>
-            <a:picLocks noChangeAspect="1"/>
-          </p:cNvPicPr>
-          <p:nvPr/>
-        </p:nvPicPr>
-        <p:blipFill>
-          <a:blip r:embed="rId3">
-            <a:extLst>
-              <a:ext uri="{28A0092B-C50C-407E-A947-70E740481C1C}">
-                <a14:useLocalDpi xmlns:a14="http://schemas.microsoft.com/office/drawing/2010/main" val="0"/>
-              </a:ext>
-            </a:extLst>
-          </a:blip>
-          <a:stretch>
-            <a:fillRect/>
-          </a:stretch>
-        </p:blipFill>
-        <p:spPr>
-          <a:xfrm>
-            <a:off x="6096000" y="282446"/>
-            <a:ext cx="6029324" cy="3146554"/>
-          </a:xfrm>
-          <a:prstGeom prst="rect">
-            <a:avLst/>
-          </a:prstGeom>
-        </p:spPr>
-      </p:pic>
-      <p:pic>
-        <p:nvPicPr>
-          <p:cNvPr id="13" name="圖片 12" descr="一張含有 文字, 圖表, 螢幕擷取畫面, 行 的圖片&#10;&#10;AI 產生的內容可能不正確。">
-            <a:extLst>
-              <a:ext uri="{FF2B5EF4-FFF2-40B4-BE49-F238E27FC236}">
-                <a16:creationId xmlns:a16="http://schemas.microsoft.com/office/drawing/2014/main" id="{6212B6EC-44DF-DF8E-1309-106A0FBC20C7}"/>
-              </a:ext>
-            </a:extLst>
-          </p:cNvPr>
-          <p:cNvPicPr>
-            <a:picLocks noChangeAspect="1"/>
-          </p:cNvPicPr>
-          <p:nvPr/>
-        </p:nvPicPr>
-        <p:blipFill>
-          <a:blip r:embed="rId4">
-            <a:extLst>
-              <a:ext uri="{28A0092B-C50C-407E-A947-70E740481C1C}">
-                <a14:useLocalDpi xmlns:a14="http://schemas.microsoft.com/office/drawing/2010/main" val="0"/>
-              </a:ext>
-            </a:extLst>
-          </a:blip>
-          <a:stretch>
-            <a:fillRect/>
-          </a:stretch>
-        </p:blipFill>
-        <p:spPr>
-          <a:xfrm>
-            <a:off x="66676" y="3429000"/>
-            <a:ext cx="6029324" cy="3146554"/>
-          </a:xfrm>
-          <a:prstGeom prst="rect">
-            <a:avLst/>
-          </a:prstGeom>
-        </p:spPr>
-      </p:pic>
-      <p:pic>
-        <p:nvPicPr>
-          <p:cNvPr id="15" name="圖片 14" descr="一張含有 文字, 螢幕擷取畫面, 行, 圖表 的圖片&#10;&#10;AI 產生的內容可能不正確。">
-            <a:extLst>
-              <a:ext uri="{FF2B5EF4-FFF2-40B4-BE49-F238E27FC236}">
-                <a16:creationId xmlns:a16="http://schemas.microsoft.com/office/drawing/2014/main" id="{AFE6E551-1031-1BA1-24A2-5E45EE615500}"/>
-              </a:ext>
-            </a:extLst>
-          </p:cNvPr>
-          <p:cNvPicPr>
-            <a:picLocks noChangeAspect="1"/>
-          </p:cNvPicPr>
-          <p:nvPr/>
-        </p:nvPicPr>
-        <p:blipFill>
-          <a:blip r:embed="rId5">
-            <a:extLst>
-              <a:ext uri="{28A0092B-C50C-407E-A947-70E740481C1C}">
-                <a14:useLocalDpi xmlns:a14="http://schemas.microsoft.com/office/drawing/2010/main" val="0"/>
-              </a:ext>
-            </a:extLst>
-          </a:blip>
-          <a:stretch>
-            <a:fillRect/>
-          </a:stretch>
-        </p:blipFill>
-        <p:spPr>
-          <a:xfrm>
-            <a:off x="6096000" y="3429000"/>
-            <a:ext cx="6029324" cy="3146554"/>
-          </a:xfrm>
-          <a:prstGeom prst="rect">
-            <a:avLst/>
-          </a:prstGeom>
-        </p:spPr>
-      </p:pic>
-    </p:spTree>
-    <p:extLst>
-      <p:ext uri="{BB962C8B-B14F-4D97-AF65-F5344CB8AC3E}">
-        <p14:creationId xmlns:p14="http://schemas.microsoft.com/office/powerpoint/2010/main" val="3149724522"/>
-      </p:ext>
-    </p:extLst>
-  </p:cSld>
-  <p:clrMapOvr>
-    <a:masterClrMapping/>
-  </p:clrMapOvr>
-</p:sld>
-</file>
-
-<file path=ppt/slides/slide5.xml><?xml version="1.0" encoding="utf-8"?>
-<p:sld xmlns:a="http://schemas.openxmlformats.org/drawingml/2006/main" xmlns:r="http://schemas.openxmlformats.org/officeDocument/2006/relationships" xmlns:p="http://schemas.openxmlformats.org/presentationml/2006/main">
-  <p:cSld>
-    <p:spTree>
-      <p:nvGrpSpPr>
-        <p:cNvPr id="1" name="">
-          <a:extLst>
-            <a:ext uri="{FF2B5EF4-FFF2-40B4-BE49-F238E27FC236}">
-              <a16:creationId xmlns:a16="http://schemas.microsoft.com/office/drawing/2014/main" id="{78A540E3-A324-F76C-2EC3-B2748C428354}"/>
-            </a:ext>
-          </a:extLst>
-        </p:cNvPr>
-        <p:cNvGrpSpPr/>
-        <p:nvPr/>
-      </p:nvGrpSpPr>
-      <p:grpSpPr>
-        <a:xfrm>
-          <a:off x="0" y="0"/>
-          <a:ext cx="0" cy="0"/>
-          <a:chOff x="0" y="0"/>
-          <a:chExt cx="0" cy="0"/>
-        </a:xfrm>
-      </p:grpSpPr>
-      <p:sp>
-        <p:nvSpPr>
-          <p:cNvPr id="6" name="文字方塊 5">
-            <a:extLst>
-              <a:ext uri="{FF2B5EF4-FFF2-40B4-BE49-F238E27FC236}">
-                <a16:creationId xmlns:a16="http://schemas.microsoft.com/office/drawing/2014/main" id="{4947B661-201E-343D-9A40-63D1D872EAB0}"/>
-              </a:ext>
-            </a:extLst>
-          </p:cNvPr>
-          <p:cNvSpPr txBox="1"/>
-          <p:nvPr/>
-        </p:nvSpPr>
-        <p:spPr>
-          <a:xfrm>
-            <a:off x="857251" y="343499"/>
-            <a:ext cx="9191624" cy="707886"/>
-          </a:xfrm>
-          <a:prstGeom prst="rect">
-            <a:avLst/>
-          </a:prstGeom>
-          <a:noFill/>
-        </p:spPr>
-        <p:txBody>
-          <a:bodyPr wrap="square" rtlCol="0">
-            <a:spAutoFit/>
-          </a:bodyPr>
-          <a:lstStyle/>
-          <a:p>
-            <a:r>
-              <a:rPr lang="en-US" altLang="zh-TW" sz="4000" dirty="0">
-                <a:latin typeface="Times New Roman" panose="02020603050405020304" pitchFamily="18" charset="0"/>
-                <a:cs typeface="Times New Roman" panose="02020603050405020304" pitchFamily="18" charset="0"/>
-              </a:rPr>
-              <a:t>Fitting with Phase-Offset-Removed Data</a:t>
-            </a:r>
-          </a:p>
-        </p:txBody>
-      </p:sp>
-      <p:pic>
-        <p:nvPicPr>
-          <p:cNvPr id="3" name="圖片 2">
-            <a:extLst>
-              <a:ext uri="{FF2B5EF4-FFF2-40B4-BE49-F238E27FC236}">
-                <a16:creationId xmlns:a16="http://schemas.microsoft.com/office/drawing/2014/main" id="{25A74F6A-2371-CDB5-2562-011E8A65F9A2}"/>
-              </a:ext>
-            </a:extLst>
-          </p:cNvPr>
-          <p:cNvPicPr>
-            <a:picLocks noChangeAspect="1"/>
-          </p:cNvPicPr>
-          <p:nvPr/>
-        </p:nvPicPr>
-        <p:blipFill>
-          <a:blip r:embed="rId2"/>
-          <a:stretch>
-            <a:fillRect/>
-          </a:stretch>
-        </p:blipFill>
-        <p:spPr>
-          <a:xfrm>
-            <a:off x="2306937" y="1447512"/>
-            <a:ext cx="7578126" cy="4324637"/>
-          </a:xfrm>
-          <a:prstGeom prst="rect">
-            <a:avLst/>
-          </a:prstGeom>
-        </p:spPr>
-      </p:pic>
-    </p:spTree>
-    <p:extLst>
-      <p:ext uri="{BB962C8B-B14F-4D97-AF65-F5344CB8AC3E}">
-        <p14:creationId xmlns:p14="http://schemas.microsoft.com/office/powerpoint/2010/main" val="2985807874"/>
-      </p:ext>
-    </p:extLst>
-  </p:cSld>
-  <p:clrMapOvr>
-    <a:masterClrMapping/>
-  </p:clrMapOvr>
-</p:sld>
-</file>
-
-<file path=ppt/slides/slide6.xml><?xml version="1.0" encoding="utf-8"?>
-<p:sld xmlns:a="http://schemas.openxmlformats.org/drawingml/2006/main" xmlns:r="http://schemas.openxmlformats.org/officeDocument/2006/relationships" xmlns:p="http://schemas.openxmlformats.org/presentationml/2006/main">
-  <p:cSld>
-    <p:spTree>
-      <p:nvGrpSpPr>
-        <p:cNvPr id="1" name=""/>
-        <p:cNvGrpSpPr/>
-        <p:nvPr/>
-      </p:nvGrpSpPr>
-      <p:grpSpPr>
-        <a:xfrm>
-          <a:off x="0" y="0"/>
-          <a:ext cx="0" cy="0"/>
-          <a:chOff x="0" y="0"/>
-          <a:chExt cx="0" cy="0"/>
-        </a:xfrm>
-      </p:grpSpPr>
-      <p:pic>
-        <p:nvPicPr>
-          <p:cNvPr id="4" name="圖片 3" descr="一張含有 文字, 圖表, 行, 繪圖 的圖片&#10;&#10;AI 產生的內容可能不正確。">
-            <a:extLst>
-              <a:ext uri="{FF2B5EF4-FFF2-40B4-BE49-F238E27FC236}">
-                <a16:creationId xmlns:a16="http://schemas.microsoft.com/office/drawing/2014/main" id="{BD0ED5AB-933D-FF2B-BBD3-78561D289F8F}"/>
-              </a:ext>
-            </a:extLst>
-          </p:cNvPr>
-          <p:cNvPicPr>
-            <a:picLocks noChangeAspect="1"/>
-          </p:cNvPicPr>
-          <p:nvPr/>
-        </p:nvPicPr>
-        <p:blipFill>
-          <a:blip r:embed="rId2">
-            <a:extLst>
-              <a:ext uri="{28A0092B-C50C-407E-A947-70E740481C1C}">
-                <a14:useLocalDpi xmlns:a14="http://schemas.microsoft.com/office/drawing/2010/main" val="0"/>
-              </a:ext>
-            </a:extLst>
-          </a:blip>
-          <a:stretch>
-            <a:fillRect/>
-          </a:stretch>
-        </p:blipFill>
-        <p:spPr>
-          <a:xfrm>
-            <a:off x="171450" y="2533650"/>
-            <a:ext cx="6096000" cy="3048000"/>
-          </a:xfrm>
-          <a:prstGeom prst="rect">
-            <a:avLst/>
-          </a:prstGeom>
-        </p:spPr>
-      </p:pic>
-      <p:pic>
-        <p:nvPicPr>
-          <p:cNvPr id="5" name="圖片 4" descr="一張含有 文字, 圖表, 行, 繪圖 的圖片&#10;&#10;AI 產生的內容可能不正確。">
-            <a:extLst>
-              <a:ext uri="{FF2B5EF4-FFF2-40B4-BE49-F238E27FC236}">
-                <a16:creationId xmlns:a16="http://schemas.microsoft.com/office/drawing/2014/main" id="{61B53945-A255-87A5-7555-4CA334C137AE}"/>
-              </a:ext>
-            </a:extLst>
-          </p:cNvPr>
-          <p:cNvPicPr>
-            <a:picLocks noChangeAspect="1"/>
-          </p:cNvPicPr>
-          <p:nvPr/>
-        </p:nvPicPr>
-        <p:blipFill>
-          <a:blip r:embed="rId3">
-            <a:extLst>
-              <a:ext uri="{28A0092B-C50C-407E-A947-70E740481C1C}">
-                <a14:useLocalDpi xmlns:a14="http://schemas.microsoft.com/office/drawing/2010/main" val="0"/>
-              </a:ext>
-            </a:extLst>
-          </a:blip>
-          <a:stretch>
-            <a:fillRect/>
-          </a:stretch>
-        </p:blipFill>
-        <p:spPr>
-          <a:xfrm>
-            <a:off x="6096000" y="2533650"/>
-            <a:ext cx="6096000" cy="3048000"/>
-          </a:xfrm>
-          <a:prstGeom prst="rect">
-            <a:avLst/>
-          </a:prstGeom>
-        </p:spPr>
-      </p:pic>
-      <p:sp>
-        <p:nvSpPr>
-          <p:cNvPr id="6" name="文字方塊 5">
-            <a:extLst>
-              <a:ext uri="{FF2B5EF4-FFF2-40B4-BE49-F238E27FC236}">
-                <a16:creationId xmlns:a16="http://schemas.microsoft.com/office/drawing/2014/main" id="{0A7EF699-5A81-8948-5B1C-7549C51C21D7}"/>
-              </a:ext>
-            </a:extLst>
-          </p:cNvPr>
-          <p:cNvSpPr txBox="1"/>
-          <p:nvPr/>
-        </p:nvSpPr>
-        <p:spPr>
-          <a:xfrm>
-            <a:off x="857251" y="810224"/>
-            <a:ext cx="4438649" cy="707886"/>
-          </a:xfrm>
-          <a:prstGeom prst="rect">
-            <a:avLst/>
-          </a:prstGeom>
-          <a:noFill/>
-        </p:spPr>
-        <p:txBody>
-          <a:bodyPr wrap="square" rtlCol="0">
-            <a:spAutoFit/>
-          </a:bodyPr>
-          <a:lstStyle/>
-          <a:p>
-            <a:r>
-              <a:rPr lang="en-US" altLang="zh-TW" sz="4000" dirty="0">
-                <a:latin typeface="Times New Roman" panose="02020603050405020304" pitchFamily="18" charset="0"/>
-                <a:cs typeface="Times New Roman" panose="02020603050405020304" pitchFamily="18" charset="0"/>
-              </a:rPr>
-              <a:t>Comparison Results</a:t>
-            </a:r>
-          </a:p>
-        </p:txBody>
-      </p:sp>
-    </p:spTree>
-    <p:extLst>
-      <p:ext uri="{BB962C8B-B14F-4D97-AF65-F5344CB8AC3E}">
-        <p14:creationId xmlns:p14="http://schemas.microsoft.com/office/powerpoint/2010/main" val="1549243866"/>
-      </p:ext>
-    </p:extLst>
-  </p:cSld>
-  <p:clrMapOvr>
-    <a:masterClrMapping/>
-  </p:clrMapOvr>
-</p:sld>
-</file>
-
-<file path=ppt/slides/slide7.xml><?xml version="1.0" encoding="utf-8"?>
-<p:sld xmlns:a="http://schemas.openxmlformats.org/drawingml/2006/main" xmlns:r="http://schemas.openxmlformats.org/officeDocument/2006/relationships" xmlns:p="http://schemas.openxmlformats.org/presentationml/2006/main">
-  <p:cSld>
-    <p:spTree>
-      <p:nvGrpSpPr>
-        <p:cNvPr id="1" name="">
-          <a:extLst>
-            <a:ext uri="{FF2B5EF4-FFF2-40B4-BE49-F238E27FC236}">
-              <a16:creationId xmlns:a16="http://schemas.microsoft.com/office/drawing/2014/main" id="{3857742A-5285-C12C-15C2-75C7854EFDD6}"/>
-            </a:ext>
-          </a:extLst>
-        </p:cNvPr>
-        <p:cNvGrpSpPr/>
-        <p:nvPr/>
-      </p:nvGrpSpPr>
-      <p:grpSpPr>
-        <a:xfrm>
-          <a:off x="0" y="0"/>
-          <a:ext cx="0" cy="0"/>
-          <a:chOff x="0" y="0"/>
-          <a:chExt cx="0" cy="0"/>
-        </a:xfrm>
-      </p:grpSpPr>
-      <p:pic>
-        <p:nvPicPr>
-          <p:cNvPr id="4" name="圖片 3" descr="一張含有 文字, 圖表, 行, 繪圖 的圖片&#10;&#10;AI 產生的內容可能不正確。">
-            <a:extLst>
-              <a:ext uri="{FF2B5EF4-FFF2-40B4-BE49-F238E27FC236}">
-                <a16:creationId xmlns:a16="http://schemas.microsoft.com/office/drawing/2014/main" id="{401E473E-B890-FC1A-6BF5-37DB43CD6848}"/>
-              </a:ext>
-            </a:extLst>
-          </p:cNvPr>
-          <p:cNvPicPr>
-            <a:picLocks noChangeAspect="1"/>
-          </p:cNvPicPr>
-          <p:nvPr/>
-        </p:nvPicPr>
-        <p:blipFill>
-          <a:blip r:embed="rId2">
-            <a:extLst>
-              <a:ext uri="{28A0092B-C50C-407E-A947-70E740481C1C}">
-                <a14:useLocalDpi xmlns:a14="http://schemas.microsoft.com/office/drawing/2010/main" val="0"/>
-              </a:ext>
-            </a:extLst>
-          </a:blip>
-          <a:stretch>
-            <a:fillRect/>
-          </a:stretch>
-        </p:blipFill>
-        <p:spPr>
-          <a:xfrm>
-            <a:off x="6257925" y="3552825"/>
-            <a:ext cx="6096000" cy="3048000"/>
-          </a:xfrm>
-          <a:prstGeom prst="rect">
-            <a:avLst/>
-          </a:prstGeom>
-        </p:spPr>
-      </p:pic>
-      <p:pic>
-        <p:nvPicPr>
-          <p:cNvPr id="11" name="圖片 10" descr="一張含有 文字, 圖表, 行, 方案 的圖片&#10;&#10;AI 產生的內容可能不正確。">
-            <a:extLst>
-              <a:ext uri="{FF2B5EF4-FFF2-40B4-BE49-F238E27FC236}">
-                <a16:creationId xmlns:a16="http://schemas.microsoft.com/office/drawing/2014/main" id="{EBFB32DF-EABB-F413-8529-5E1BAB7AB0D6}"/>
-              </a:ext>
-            </a:extLst>
-          </p:cNvPr>
-          <p:cNvPicPr>
-            <a:picLocks noChangeAspect="1"/>
-          </p:cNvPicPr>
-          <p:nvPr/>
-        </p:nvPicPr>
-        <p:blipFill>
-          <a:blip r:embed="rId3">
-            <a:extLst>
-              <a:ext uri="{28A0092B-C50C-407E-A947-70E740481C1C}">
-                <a14:useLocalDpi xmlns:a14="http://schemas.microsoft.com/office/drawing/2010/main" val="0"/>
-              </a:ext>
-            </a:extLst>
-          </a:blip>
-          <a:stretch>
-            <a:fillRect/>
-          </a:stretch>
-        </p:blipFill>
-        <p:spPr>
-          <a:xfrm>
-            <a:off x="6257925" y="381000"/>
-            <a:ext cx="6096000" cy="3048000"/>
-          </a:xfrm>
-          <a:prstGeom prst="rect">
-            <a:avLst/>
-          </a:prstGeom>
-        </p:spPr>
-      </p:pic>
-      <p:pic>
-        <p:nvPicPr>
-          <p:cNvPr id="13" name="圖片 12" descr="一張含有 文字, 圖表, 行, 繪圖 的圖片&#10;&#10;AI 產生的內容可能不正確。">
-            <a:extLst>
-              <a:ext uri="{FF2B5EF4-FFF2-40B4-BE49-F238E27FC236}">
-                <a16:creationId xmlns:a16="http://schemas.microsoft.com/office/drawing/2014/main" id="{22F0A6BF-BF02-E895-5276-4A6D3D60A056}"/>
-              </a:ext>
-            </a:extLst>
-          </p:cNvPr>
-          <p:cNvPicPr>
-            <a:picLocks noChangeAspect="1"/>
-          </p:cNvPicPr>
-          <p:nvPr/>
-        </p:nvPicPr>
-        <p:blipFill>
-          <a:blip r:embed="rId4">
-            <a:extLst>
-              <a:ext uri="{28A0092B-C50C-407E-A947-70E740481C1C}">
-                <a14:useLocalDpi xmlns:a14="http://schemas.microsoft.com/office/drawing/2010/main" val="0"/>
-              </a:ext>
-            </a:extLst>
-          </a:blip>
-          <a:stretch>
-            <a:fillRect/>
-          </a:stretch>
-        </p:blipFill>
-        <p:spPr>
-          <a:xfrm>
-            <a:off x="295275" y="381000"/>
-            <a:ext cx="6096000" cy="3048000"/>
-          </a:xfrm>
-          <a:prstGeom prst="rect">
-            <a:avLst/>
-          </a:prstGeom>
-        </p:spPr>
-      </p:pic>
-      <p:pic>
-        <p:nvPicPr>
-          <p:cNvPr id="15" name="圖片 14" descr="一張含有 文字, 圖表, 行, 繪圖 的圖片&#10;&#10;AI 產生的內容可能不正確。">
-            <a:extLst>
-              <a:ext uri="{FF2B5EF4-FFF2-40B4-BE49-F238E27FC236}">
-                <a16:creationId xmlns:a16="http://schemas.microsoft.com/office/drawing/2014/main" id="{AF991C54-FF4B-C025-6A86-203450C334A4}"/>
-              </a:ext>
-            </a:extLst>
-          </p:cNvPr>
-          <p:cNvPicPr>
-            <a:picLocks noChangeAspect="1"/>
-          </p:cNvPicPr>
-          <p:nvPr/>
-        </p:nvPicPr>
-        <p:blipFill>
-          <a:blip r:embed="rId5">
-            <a:extLst>
-              <a:ext uri="{28A0092B-C50C-407E-A947-70E740481C1C}">
-                <a14:useLocalDpi xmlns:a14="http://schemas.microsoft.com/office/drawing/2010/main" val="0"/>
-              </a:ext>
-            </a:extLst>
-          </a:blip>
-          <a:stretch>
-            <a:fillRect/>
-          </a:stretch>
-        </p:blipFill>
-        <p:spPr>
-          <a:xfrm>
-            <a:off x="295275" y="3676650"/>
-            <a:ext cx="6096000" cy="3048000"/>
-          </a:xfrm>
-          <a:prstGeom prst="rect">
-            <a:avLst/>
-          </a:prstGeom>
-        </p:spPr>
-      </p:pic>
-    </p:spTree>
-    <p:extLst>
-      <p:ext uri="{BB962C8B-B14F-4D97-AF65-F5344CB8AC3E}">
-        <p14:creationId xmlns:p14="http://schemas.microsoft.com/office/powerpoint/2010/main" val="2686757437"/>
-      </p:ext>
-    </p:extLst>
-  </p:cSld>
-  <p:clrMapOvr>
-    <a:masterClrMapping/>
-  </p:clrMapOvr>
-</p:sld>
-</file>
-
-<file path=ppt/slides/slide8.xml><?xml version="1.0" encoding="utf-8"?>
-<p:sld xmlns:a="http://schemas.openxmlformats.org/drawingml/2006/main" xmlns:r="http://schemas.openxmlformats.org/officeDocument/2006/relationships" xmlns:p="http://schemas.openxmlformats.org/presentationml/2006/main">
-  <p:cSld>
-    <p:spTree>
-      <p:nvGrpSpPr>
-        <p:cNvPr id="1" name=""/>
-        <p:cNvGrpSpPr/>
-        <p:nvPr/>
-      </p:nvGrpSpPr>
-      <p:grpSpPr>
-        <a:xfrm>
-          <a:off x="0" y="0"/>
-          <a:ext cx="0" cy="0"/>
-          <a:chOff x="0" y="0"/>
-          <a:chExt cx="0" cy="0"/>
-        </a:xfrm>
-      </p:grpSpPr>
-      <p:pic>
-        <p:nvPicPr>
-          <p:cNvPr id="9" name="圖片 8" descr="一張含有 文字, 圖表, 行, 螢幕擷取畫面 的圖片&#10;&#10;AI 產生的內容可能不正確。">
-            <a:extLst>
-              <a:ext uri="{FF2B5EF4-FFF2-40B4-BE49-F238E27FC236}">
-                <a16:creationId xmlns:a16="http://schemas.microsoft.com/office/drawing/2014/main" id="{5C0E80BF-1D20-0B13-BE0D-851E78672344}"/>
-              </a:ext>
-            </a:extLst>
-          </p:cNvPr>
-          <p:cNvPicPr>
-            <a:picLocks noChangeAspect="1"/>
-          </p:cNvPicPr>
-          <p:nvPr/>
-        </p:nvPicPr>
-        <p:blipFill>
-          <a:blip r:embed="rId2">
-            <a:extLst>
-              <a:ext uri="{28A0092B-C50C-407E-A947-70E740481C1C}">
-                <a14:useLocalDpi xmlns:a14="http://schemas.microsoft.com/office/drawing/2010/main" val="0"/>
-              </a:ext>
-            </a:extLst>
-          </a:blip>
-          <a:stretch>
-            <a:fillRect/>
-          </a:stretch>
-        </p:blipFill>
-        <p:spPr>
-          <a:xfrm>
-            <a:off x="-62513" y="1475076"/>
-            <a:ext cx="6531315" cy="4124535"/>
-          </a:xfrm>
-          <a:prstGeom prst="rect">
-            <a:avLst/>
-          </a:prstGeom>
-        </p:spPr>
-      </p:pic>
-      <p:pic>
-        <p:nvPicPr>
-          <p:cNvPr id="11" name="圖片 10" descr="一張含有 文字, 圖表, 行, 螢幕擷取畫面 的圖片&#10;&#10;AI 產生的內容可能不正確。">
-            <a:extLst>
-              <a:ext uri="{FF2B5EF4-FFF2-40B4-BE49-F238E27FC236}">
-                <a16:creationId xmlns:a16="http://schemas.microsoft.com/office/drawing/2014/main" id="{857EF3F0-19CF-90CC-7E2E-209834FC4077}"/>
-              </a:ext>
-            </a:extLst>
-          </p:cNvPr>
-          <p:cNvPicPr>
-            <a:picLocks noChangeAspect="1"/>
-          </p:cNvPicPr>
-          <p:nvPr/>
-        </p:nvPicPr>
-        <p:blipFill>
-          <a:blip r:embed="rId3">
-            <a:extLst>
-              <a:ext uri="{28A0092B-C50C-407E-A947-70E740481C1C}">
-                <a14:useLocalDpi xmlns:a14="http://schemas.microsoft.com/office/drawing/2010/main" val="0"/>
-              </a:ext>
-            </a:extLst>
-          </a:blip>
-          <a:stretch>
-            <a:fillRect/>
-          </a:stretch>
-        </p:blipFill>
-        <p:spPr>
-          <a:xfrm>
-            <a:off x="5863305" y="1475076"/>
-            <a:ext cx="6531315" cy="4124535"/>
-          </a:xfrm>
-          <a:prstGeom prst="rect">
-            <a:avLst/>
-          </a:prstGeom>
-        </p:spPr>
-      </p:pic>
-    </p:spTree>
-    <p:extLst>
-      <p:ext uri="{BB962C8B-B14F-4D97-AF65-F5344CB8AC3E}">
-        <p14:creationId xmlns:p14="http://schemas.microsoft.com/office/powerpoint/2010/main" val="2136732979"/>
+        <p14:creationId xmlns:p14="http://schemas.microsoft.com/office/powerpoint/2010/main" val="144192149"/>
       </p:ext>
     </p:extLst>
   </p:cSld>
@@ -7452,10 +8212,10 @@
       </p:grpSpPr>
       <p:pic>
         <p:nvPicPr>
-          <p:cNvPr id="5" name="圖片 4" descr="一張含有 文字, 圖表, 行, 螢幕擷取畫面 的圖片&#10;&#10;AI 產生的內容可能不正確。">
-            <a:extLst>
-              <a:ext uri="{FF2B5EF4-FFF2-40B4-BE49-F238E27FC236}">
-                <a16:creationId xmlns:a16="http://schemas.microsoft.com/office/drawing/2014/main" id="{CB4E4EB5-C0B6-5564-99FA-5E2FC90E229D}"/>
+          <p:cNvPr id="13" name="圖片 12" descr="一張含有 文字, 螢幕擷取畫面, 圖表, 行 的圖片&#10;&#10;AI 產生的內容可能不正確。">
+            <a:extLst>
+              <a:ext uri="{FF2B5EF4-FFF2-40B4-BE49-F238E27FC236}">
+                <a16:creationId xmlns:a16="http://schemas.microsoft.com/office/drawing/2014/main" id="{7D0C073B-DD88-BE84-9F4B-9920469D8007}"/>
               </a:ext>
             </a:extLst>
           </p:cNvPr>
@@ -7478,8 +8238,8 @@
         </p:blipFill>
         <p:spPr>
           <a:xfrm>
-            <a:off x="-113507" y="1376039"/>
-            <a:ext cx="6501840" cy="4105922"/>
+            <a:off x="6205091" y="1322616"/>
+            <a:ext cx="5903218" cy="5257800"/>
           </a:xfrm>
           <a:prstGeom prst="rect">
             <a:avLst/>
@@ -7488,10 +8248,10 @@
       </p:pic>
       <p:pic>
         <p:nvPicPr>
-          <p:cNvPr id="7" name="圖片 6" descr="一張含有 文字, 圖表, 行, 螢幕擷取畫面 的圖片&#10;&#10;AI 產生的內容可能不正確。">
-            <a:extLst>
-              <a:ext uri="{FF2B5EF4-FFF2-40B4-BE49-F238E27FC236}">
-                <a16:creationId xmlns:a16="http://schemas.microsoft.com/office/drawing/2014/main" id="{33DC19FB-7869-1479-475A-71F17B4EADAC}"/>
+          <p:cNvPr id="15" name="圖片 14" descr="一張含有 文字, 螢幕擷取畫面, 圖表, 行 的圖片&#10;&#10;AI 產生的內容可能不正確。">
+            <a:extLst>
+              <a:ext uri="{FF2B5EF4-FFF2-40B4-BE49-F238E27FC236}">
+                <a16:creationId xmlns:a16="http://schemas.microsoft.com/office/drawing/2014/main" id="{D0AB2032-110F-187A-D97F-ADC8639C8FBB}"/>
               </a:ext>
             </a:extLst>
           </p:cNvPr>
@@ -7514,18 +8274,112 @@
         </p:blipFill>
         <p:spPr>
           <a:xfrm>
-            <a:off x="5945709" y="1376039"/>
-            <a:ext cx="6501840" cy="4105922"/>
+            <a:off x="192782" y="1322616"/>
+            <a:ext cx="5903218" cy="5257800"/>
           </a:xfrm>
           <a:prstGeom prst="rect">
             <a:avLst/>
           </a:prstGeom>
         </p:spPr>
       </p:pic>
+      <p:sp>
+        <p:nvSpPr>
+          <p:cNvPr id="2" name="標題 1">
+            <a:extLst>
+              <a:ext uri="{FF2B5EF4-FFF2-40B4-BE49-F238E27FC236}">
+                <a16:creationId xmlns:a16="http://schemas.microsoft.com/office/drawing/2014/main" id="{B1CDE4DF-2773-F426-EF30-A9CBBFF14747}"/>
+              </a:ext>
+            </a:extLst>
+          </p:cNvPr>
+          <p:cNvSpPr>
+            <a:spLocks noGrp="1"/>
+          </p:cNvSpPr>
+          <p:nvPr>
+            <p:ph type="title"/>
+          </p:nvPr>
+        </p:nvSpPr>
+        <p:spPr>
+          <a:xfrm>
+            <a:off x="11096897" y="0"/>
+            <a:ext cx="1095103" cy="662486"/>
+          </a:xfrm>
+        </p:spPr>
+        <p:txBody>
+          <a:bodyPr>
+            <a:normAutofit fontScale="90000"/>
+          </a:bodyPr>
+          <a:lstStyle/>
+          <a:p>
+            <a:r>
+              <a:rPr lang="en-US" altLang="zh-TW" dirty="0">
+                <a:latin typeface="Times New Roman" panose="02020603050405020304" pitchFamily="18" charset="0"/>
+                <a:cs typeface="Times New Roman" panose="02020603050405020304" pitchFamily="18" charset="0"/>
+              </a:rPr>
+              <a:t>10/2</a:t>
+            </a:r>
+            <a:endParaRPr lang="zh-TW" altLang="en-US" dirty="0">
+              <a:latin typeface="Times New Roman" panose="02020603050405020304" pitchFamily="18" charset="0"/>
+              <a:cs typeface="Times New Roman" panose="02020603050405020304" pitchFamily="18" charset="0"/>
+            </a:endParaRPr>
+          </a:p>
+        </p:txBody>
+      </p:sp>
+      <p:sp>
+        <p:nvSpPr>
+          <p:cNvPr id="3" name="文字方塊 2">
+            <a:extLst>
+              <a:ext uri="{FF2B5EF4-FFF2-40B4-BE49-F238E27FC236}">
+                <a16:creationId xmlns:a16="http://schemas.microsoft.com/office/drawing/2014/main" id="{7530D3CD-F426-7375-3EF2-623A6A6ED907}"/>
+              </a:ext>
+            </a:extLst>
+          </p:cNvPr>
+          <p:cNvSpPr txBox="1"/>
+          <p:nvPr/>
+        </p:nvSpPr>
+        <p:spPr>
+          <a:xfrm>
+            <a:off x="857251" y="343499"/>
+            <a:ext cx="9191624" cy="707886"/>
+          </a:xfrm>
+          <a:prstGeom prst="rect">
+            <a:avLst/>
+          </a:prstGeom>
+          <a:noFill/>
+        </p:spPr>
+        <p:txBody>
+          <a:bodyPr wrap="square" rtlCol="0">
+            <a:spAutoFit/>
+          </a:bodyPr>
+          <a:lstStyle/>
+          <a:p>
+            <a:r>
+              <a:rPr lang="en-US" altLang="zh-TW" sz="4000" dirty="0">
+                <a:latin typeface="Times New Roman" panose="02020603050405020304" pitchFamily="18" charset="0"/>
+                <a:cs typeface="Times New Roman" panose="02020603050405020304" pitchFamily="18" charset="0"/>
+              </a:rPr>
+              <a:t>Different </a:t>
+            </a:r>
+            <a:r>
+              <a:rPr lang="en-US" altLang="zh-TW" sz="4000" dirty="0" err="1">
+                <a:latin typeface="Times New Roman" panose="02020603050405020304" pitchFamily="18" charset="0"/>
+                <a:cs typeface="Times New Roman" panose="02020603050405020304" pitchFamily="18" charset="0"/>
+              </a:rPr>
+              <a:t>Wc</a:t>
+            </a:r>
+            <a:r>
+              <a:rPr lang="en-US" altLang="zh-TW" sz="4000" dirty="0">
+                <a:latin typeface="Times New Roman" panose="02020603050405020304" pitchFamily="18" charset="0"/>
+                <a:cs typeface="Times New Roman" panose="02020603050405020304" pitchFamily="18" charset="0"/>
+              </a:rPr>
+              <a:t> Comparison</a:t>
+            </a:r>
+          </a:p>
+        </p:txBody>
+      </p:sp>
     </p:spTree>
     <p:extLst>
       <p:ext uri="{BB962C8B-B14F-4D97-AF65-F5344CB8AC3E}">
-        <p14:creationId xmlns:p14="http://schemas.microsoft.com/office/powerpoint/2010/main" val="3257696351"/>
+        <p14:creationId xmlns:p14="http://schemas.microsoft.com/office/powerpoint/2010/main" val="2990117587"/>
       </p:ext>
     </p:extLst>
   </p:cSld>

</xml_diff>